<commit_message>
feat(hsk2): On tap tong hop Phan 2 - 38 nhom on ~190 tu vung qua cau vi du/duc lo, anh CC + audio; gop Phan 1+2 thanh Buoi-Ontap-Full.pptx
Co-Authored-By: Claude Sonnet 5 <noreply@anthropic.com>
</commit_message>
<xml_diff>
--- a/output/hsk2/on_ontap/slide/Buoi-Ontap-P1-NguPhap.pptx
+++ b/output/hsk2/on_ontap/slide/Buoi-Ontap-P1-NguPhap.pptx
@@ -7915,9 +7915,45 @@
           </a:graphicData>
         </a:graphic>
       </p:graphicFrame>
-      <p:sp>
-        <p:nvSpPr>
-          <p:cNvPr id="7" name="TextBox 6"/>
+      <p:pic>
+        <p:nvPicPr>
+          <p:cNvPr id="7" name="slide20.mp3">
+            <a:hlinkClick r:id="" action="ppaction://media"/>
+          </p:cNvPr>
+          <p:cNvPicPr>
+            <a:picLocks noChangeAspect="1"/>
+          </p:cNvPicPr>
+          <p:nvPr>
+            <a:videoFile r:link="rId3"/>
+            <p:extLst>
+              <p:ext uri="{DAA4B4D4-6D71-4841-9C94-3DE7FCFB9230}">
+                <p14:media xmlns:p14="http://schemas.microsoft.com/office/powerpoint/2010/main" r:embed="rId2"/>
+              </p:ext>
+            </p:extLst>
+          </p:nvPr>
+        </p:nvPicPr>
+        <p:blipFill>
+          <a:blip r:embed="rId4"/>
+          <a:stretch>
+            <a:fillRect/>
+          </a:stretch>
+        </p:blipFill>
+        <p:spPr>
+          <a:xfrm>
+            <a:off x="11076127" y="320040"/>
+            <a:ext cx="566928" cy="566928"/>
+          </a:xfrm>
+          <a:prstGeom prst="rect">
+            <a:avLst/>
+          </a:prstGeom>
+          <a:ln>
+            <a:noFill/>
+          </a:ln>
+        </p:spPr>
+      </p:pic>
+      <p:sp>
+        <p:nvSpPr>
+          <p:cNvPr id="8" name="TextBox 7"/>
           <p:cNvSpPr txBox="1"/>
           <p:nvPr/>
         </p:nvSpPr>
@@ -7959,6 +7995,28 @@
   <p:clrMapOvr>
     <a:masterClrMapping/>
   </p:clrMapOvr>
+  <p:timing>
+    <p:tnLst>
+      <p:par>
+        <p:cTn id="1" dur="indefinite" restart="never" nodeType="tmRoot">
+          <p:childTnLst>
+            <p:video>
+              <p:cMediaNode vol="80000">
+                <p:cTn id="2" fill="hold" display="0">
+                  <p:stCondLst>
+                    <p:cond delay="indefinite"/>
+                  </p:stCondLst>
+                </p:cTn>
+                <p:tgtEl>
+                  <p:spTgt spid="7"/>
+                </p:tgtEl>
+              </p:cMediaNode>
+            </p:video>
+          </p:childTnLst>
+        </p:cTn>
+      </p:par>
+    </p:tnLst>
+  </p:timing>
 </p:sld>
 </file>
 
@@ -9174,9 +9232,45 @@
           </a:graphicData>
         </a:graphic>
       </p:graphicFrame>
-      <p:sp>
-        <p:nvSpPr>
-          <p:cNvPr id="7" name="TextBox 6"/>
+      <p:pic>
+        <p:nvPicPr>
+          <p:cNvPr id="7" name="slide21.mp3">
+            <a:hlinkClick r:id="" action="ppaction://media"/>
+          </p:cNvPr>
+          <p:cNvPicPr>
+            <a:picLocks noChangeAspect="1"/>
+          </p:cNvPicPr>
+          <p:nvPr>
+            <a:videoFile r:link="rId3"/>
+            <p:extLst>
+              <p:ext uri="{DAA4B4D4-6D71-4841-9C94-3DE7FCFB9230}">
+                <p14:media xmlns:p14="http://schemas.microsoft.com/office/powerpoint/2010/main" r:embed="rId2"/>
+              </p:ext>
+            </p:extLst>
+          </p:nvPr>
+        </p:nvPicPr>
+        <p:blipFill>
+          <a:blip r:embed="rId4"/>
+          <a:stretch>
+            <a:fillRect/>
+          </a:stretch>
+        </p:blipFill>
+        <p:spPr>
+          <a:xfrm>
+            <a:off x="11076127" y="320040"/>
+            <a:ext cx="566928" cy="566928"/>
+          </a:xfrm>
+          <a:prstGeom prst="rect">
+            <a:avLst/>
+          </a:prstGeom>
+          <a:ln>
+            <a:noFill/>
+          </a:ln>
+        </p:spPr>
+      </p:pic>
+      <p:sp>
+        <p:nvSpPr>
+          <p:cNvPr id="8" name="TextBox 7"/>
           <p:cNvSpPr txBox="1"/>
           <p:nvPr/>
         </p:nvSpPr>
@@ -9218,6 +9312,28 @@
   <p:clrMapOvr>
     <a:masterClrMapping/>
   </p:clrMapOvr>
+  <p:timing>
+    <p:tnLst>
+      <p:par>
+        <p:cTn id="1" dur="indefinite" restart="never" nodeType="tmRoot">
+          <p:childTnLst>
+            <p:video>
+              <p:cMediaNode vol="80000">
+                <p:cTn id="2" fill="hold" display="0">
+                  <p:stCondLst>
+                    <p:cond delay="indefinite"/>
+                  </p:stCondLst>
+                </p:cTn>
+                <p:tgtEl>
+                  <p:spTgt spid="7"/>
+                </p:tgtEl>
+              </p:cMediaNode>
+            </p:video>
+          </p:childTnLst>
+        </p:cTn>
+      </p:par>
+    </p:tnLst>
+  </p:timing>
 </p:sld>
 </file>
 

</xml_diff>

<commit_message>
feat(hsk2): cap nhat buoi on tap + buoi 17 on HSKK + nhan xet buoi 07
Co-Authored-By: Claude Sonnet 5 <noreply@anthropic.com>
</commit_message>
<xml_diff>
--- a/output/hsk2/on_ontap/slide/Buoi-Ontap-P1-NguPhap.pptx
+++ b/output/hsk2/on_ontap/slide/Buoi-Ontap-P1-NguPhap.pptx
@@ -27,6 +27,7 @@
     <p:sldId id="275" r:id="rId26"/>
     <p:sldId id="276" r:id="rId27"/>
     <p:sldId id="277" r:id="rId28"/>
+    <p:sldId id="278" r:id="rId29"/>
   </p:sldIdLst>
   <p:sldSz cx="12191695" cy="6858000" type="screen4x3"/>
   <p:notesSz cx="6858000" cy="9144000"/>
@@ -3345,7 +3346,7 @@
         <p:spPr>
           <a:xfrm>
             <a:off x="548640" y="146304"/>
-            <a:ext cx="2349235" cy="384048"/>
+            <a:ext cx="2585923" cy="384048"/>
           </a:xfrm>
           <a:prstGeom prst="roundRect">
             <a:avLst/>
@@ -3388,7 +3389,7 @@
                 <a:ea typeface="Microsoft YaHei"/>
                 <a:cs typeface="Microsoft YaHei"/>
               </a:rPr>
-              <a:t>练习 8/17 · Bài 7</a:t>
+              <a:t>练习 7/17 · Bài 6-7</a:t>
             </a:r>
           </a:p>
         </p:txBody>
@@ -3427,7 +3428,7 @@
                 <a:ea typeface="Microsoft YaHei"/>
                 <a:cs typeface="Microsoft YaHei"/>
               </a:rPr>
-              <a:t>Sắp xếp thành câu đúng</a:t>
+              <a:t>Điền từ vào chỗ trống</a:t>
             </a:r>
           </a:p>
         </p:txBody>
@@ -3466,7 +3467,7 @@
                 <a:ea typeface="Microsoft YaHei"/>
                 <a:cs typeface="Microsoft YaHei"/>
               </a:rPr>
-              <a:t>Sắp xếp thành câu đúng:</a:t>
+              <a:t>Điền chữ còn thiếu:</a:t>
             </a:r>
           </a:p>
           <a:p>
@@ -3496,7 +3497,7 @@
                 <a:ea typeface="Microsoft YaHei"/>
                 <a:cs typeface="Microsoft YaHei"/>
               </a:rPr>
-              <a:t>一…就… — B xảy ra ngay sau A — 一 + A，就 + B</a:t>
+              <a:t>状态补语 得 — nói làm như thế nào — động từ + 得 + tính từ</a:t>
             </a:r>
           </a:p>
           <a:p>
@@ -3526,7 +3527,37 @@
                 <a:ea typeface="Microsoft YaHei"/>
                 <a:cs typeface="Microsoft YaHei"/>
               </a:rPr>
-              <a:t>他 / 就 / 一 / 下课 / 回家</a:t>
+              <a:t>他昨天睡 ___ 很晚。</a:t>
+            </a:r>
+          </a:p>
+          <a:p>
+            <a:pPr>
+              <a:spcBef>
+                <a:spcPts val="2600"/>
+              </a:spcBef>
+              <a:buNone/>
+            </a:pPr>
+            <a:r>
+              <a:rPr sz="2200" b="1" i="0">
+                <a:solidFill>
+                  <a:srgbClr val="8E2B20"/>
+                </a:solidFill>
+                <a:latin typeface="Calibri"/>
+                <a:ea typeface="Microsoft YaHei"/>
+                <a:cs typeface="Microsoft YaHei"/>
+              </a:rPr>
+              <a:t>2. </a:t>
+            </a:r>
+            <a:r>
+              <a:rPr sz="2200" b="1" i="0">
+                <a:solidFill>
+                  <a:srgbClr val="1F2933"/>
+                </a:solidFill>
+                <a:latin typeface="Calibri"/>
+                <a:ea typeface="Microsoft YaHei"/>
+                <a:cs typeface="Microsoft YaHei"/>
+              </a:rPr>
+              <a:t>她住 ___ 很远，我想送她回去。</a:t>
             </a:r>
           </a:p>
         </p:txBody>
@@ -3689,7 +3720,7 @@
                 <a:ea typeface="Microsoft YaHei"/>
                 <a:cs typeface="Microsoft YaHei"/>
               </a:rPr>
-              <a:t>练习 9/17 · Bài 8</a:t>
+              <a:t>练习 8/17 · Bài 7</a:t>
             </a:r>
           </a:p>
         </p:txBody>
@@ -3728,7 +3759,7 @@
                 <a:ea typeface="Microsoft YaHei"/>
                 <a:cs typeface="Microsoft YaHei"/>
               </a:rPr>
-              <a:t>Điền từ vào chỗ trống</a:t>
+              <a:t>Sắp xếp thành câu đúng</a:t>
             </a:r>
           </a:p>
         </p:txBody>
@@ -3767,7 +3798,7 @@
                 <a:ea typeface="Microsoft YaHei"/>
                 <a:cs typeface="Microsoft YaHei"/>
               </a:rPr>
-              <a:t>Điền từ còn thiếu:</a:t>
+              <a:t>Sắp xếp thành câu đúng:</a:t>
             </a:r>
           </a:p>
           <a:p>
@@ -3797,7 +3828,7 @@
                 <a:ea typeface="Microsoft YaHei"/>
                 <a:cs typeface="Microsoft YaHei"/>
               </a:rPr>
-              <a:t>虽然……，但是…… — tuy A nhưng B — 虽然 + A，但是 + B</a:t>
+              <a:t>一…就… — B xảy ra ngay sau A — 一 + A，就 + B</a:t>
             </a:r>
           </a:p>
           <a:p>
@@ -3827,37 +3858,7 @@
                 <a:ea typeface="Microsoft YaHei"/>
                 <a:cs typeface="Microsoft YaHei"/>
               </a:rPr>
-              <a:t>他 ___ 已经很累了，___ 还是坚持跑完了。</a:t>
-            </a:r>
-          </a:p>
-          <a:p>
-            <a:pPr>
-              <a:spcBef>
-                <a:spcPts val="2600"/>
-              </a:spcBef>
-              <a:buNone/>
-            </a:pPr>
-            <a:r>
-              <a:rPr sz="2200" b="1" i="0">
-                <a:solidFill>
-                  <a:srgbClr val="8E2B20"/>
-                </a:solidFill>
-                <a:latin typeface="Calibri"/>
-                <a:ea typeface="Microsoft YaHei"/>
-                <a:cs typeface="Microsoft YaHei"/>
-              </a:rPr>
-              <a:t>2. </a:t>
-            </a:r>
-            <a:r>
-              <a:rPr sz="2200" b="1" i="0">
-                <a:solidFill>
-                  <a:srgbClr val="1F2933"/>
-                </a:solidFill>
-                <a:latin typeface="Calibri"/>
-                <a:ea typeface="Microsoft YaHei"/>
-                <a:cs typeface="Microsoft YaHei"/>
-              </a:rPr>
-              <a:t>外边下雪了，___ 不太冷。(chỉ dùng 1 vế)</a:t>
+              <a:t>他 / 就 / 一 / 下课 / 回家</a:t>
             </a:r>
           </a:p>
         </p:txBody>
@@ -3977,7 +3978,7 @@
         <p:spPr>
           <a:xfrm>
             <a:off x="548640" y="146304"/>
-            <a:ext cx="2467579" cy="384048"/>
+            <a:ext cx="2349235" cy="384048"/>
           </a:xfrm>
           <a:prstGeom prst="roundRect">
             <a:avLst/>
@@ -4020,7 +4021,7 @@
                 <a:ea typeface="Microsoft YaHei"/>
                 <a:cs typeface="Microsoft YaHei"/>
               </a:rPr>
-              <a:t>练习 10/17 · Bài 9</a:t>
+              <a:t>练习 9/17 · Bài 8</a:t>
             </a:r>
           </a:p>
         </p:txBody>
@@ -4059,7 +4060,7 @@
                 <a:ea typeface="Microsoft YaHei"/>
                 <a:cs typeface="Microsoft YaHei"/>
               </a:rPr>
-              <a:t>Trắc nghiệm chọn câu đúng</a:t>
+              <a:t>Điền từ vào chỗ trống</a:t>
             </a:r>
           </a:p>
         </p:txBody>
@@ -4098,7 +4099,7 @@
                 <a:ea typeface="Microsoft YaHei"/>
                 <a:cs typeface="Microsoft YaHei"/>
               </a:rPr>
-              <a:t>Chọn câu ĐÚNG cho ý sau:</a:t>
+              <a:t>Điền từ còn thiếu:</a:t>
             </a:r>
           </a:p>
           <a:p>
@@ -4128,7 +4129,7 @@
                 <a:ea typeface="Microsoft YaHei"/>
                 <a:cs typeface="Microsoft YaHei"/>
               </a:rPr>
-              <a:t>动词「离」— A cách B — A + 离 + B + khoảng cách</a:t>
+              <a:t>虽然……，但是…… — tuy A nhưng B — 虽然 + A，但是 + B</a:t>
             </a:r>
           </a:p>
           <a:p>
@@ -4158,7 +4159,37 @@
                 <a:ea typeface="Microsoft YaHei"/>
                 <a:cs typeface="Microsoft YaHei"/>
               </a:rPr>
-              <a:t>'Nhà anh ấy cách nhà tôi rất gần' — A) 他家离我家很近  B) 他家很近离我家  C) 离他家我家很近</a:t>
+              <a:t>他 ___ 已经很累了，___ 还是坚持跑完了。</a:t>
+            </a:r>
+          </a:p>
+          <a:p>
+            <a:pPr>
+              <a:spcBef>
+                <a:spcPts val="2600"/>
+              </a:spcBef>
+              <a:buNone/>
+            </a:pPr>
+            <a:r>
+              <a:rPr sz="2200" b="1" i="0">
+                <a:solidFill>
+                  <a:srgbClr val="8E2B20"/>
+                </a:solidFill>
+                <a:latin typeface="Calibri"/>
+                <a:ea typeface="Microsoft YaHei"/>
+                <a:cs typeface="Microsoft YaHei"/>
+              </a:rPr>
+              <a:t>2. </a:t>
+            </a:r>
+            <a:r>
+              <a:rPr sz="2200" b="1" i="0">
+                <a:solidFill>
+                  <a:srgbClr val="1F2933"/>
+                </a:solidFill>
+                <a:latin typeface="Calibri"/>
+                <a:ea typeface="Microsoft YaHei"/>
+                <a:cs typeface="Microsoft YaHei"/>
+              </a:rPr>
+              <a:t>外边下雪了，___ 不太冷。(chỉ dùng 1 vế)</a:t>
             </a:r>
           </a:p>
         </p:txBody>
@@ -4278,7 +4309,7 @@
         <p:spPr>
           <a:xfrm>
             <a:off x="548640" y="146304"/>
-            <a:ext cx="2585923" cy="384048"/>
+            <a:ext cx="2467579" cy="384048"/>
           </a:xfrm>
           <a:prstGeom prst="roundRect">
             <a:avLst/>
@@ -4321,7 +4352,7 @@
                 <a:ea typeface="Microsoft YaHei"/>
                 <a:cs typeface="Microsoft YaHei"/>
               </a:rPr>
-              <a:t>练习 11/17 · Bài 10</a:t>
+              <a:t>练习 10/17 · Bài 9</a:t>
             </a:r>
           </a:p>
         </p:txBody>
@@ -4360,7 +4391,7 @@
                 <a:ea typeface="Microsoft YaHei"/>
                 <a:cs typeface="Microsoft YaHei"/>
               </a:rPr>
-              <a:t>Tìm và sửa câu sai</a:t>
+              <a:t>Trắc nghiệm chọn câu đúng</a:t>
             </a:r>
           </a:p>
         </p:txBody>
@@ -4399,7 +4430,7 @@
                 <a:ea typeface="Microsoft YaHei"/>
                 <a:cs typeface="Microsoft YaHei"/>
               </a:rPr>
-              <a:t>Mỗi câu sau có 1 lỗi — tìm và sửa lại:</a:t>
+              <a:t>Chọn câu ĐÚNG cho ý sau:</a:t>
             </a:r>
           </a:p>
           <a:p>
@@ -4429,7 +4460,7 @@
                 <a:ea typeface="Microsoft YaHei"/>
                 <a:cs typeface="Microsoft YaHei"/>
               </a:rPr>
-              <a:t>选择问句 — nối 2 lựa chọn trong câu hỏi — A + 还是 + B</a:t>
+              <a:t>动词「离」— A cách B — A + 离 + B + khoảng cách</a:t>
             </a:r>
           </a:p>
           <a:p>
@@ -4459,67 +4490,7 @@
                 <a:ea typeface="Microsoft YaHei"/>
                 <a:cs typeface="Microsoft YaHei"/>
               </a:rPr>
-              <a:t>你想喝茶还是咖啡还是？</a:t>
-            </a:r>
-          </a:p>
-          <a:p>
-            <a:pPr>
-              <a:spcBef>
-                <a:spcPts val="2600"/>
-              </a:spcBef>
-              <a:buNone/>
-            </a:pPr>
-            <a:r>
-              <a:rPr sz="2200" b="1" i="0">
-                <a:solidFill>
-                  <a:srgbClr val="8E2B20"/>
-                </a:solidFill>
-                <a:latin typeface="Calibri"/>
-                <a:ea typeface="Microsoft YaHei"/>
-                <a:cs typeface="Microsoft YaHei"/>
-              </a:rPr>
-              <a:t>2. </a:t>
-            </a:r>
-            <a:r>
-              <a:rPr sz="2200" b="1" i="0">
-                <a:solidFill>
-                  <a:srgbClr val="1F2933"/>
-                </a:solidFill>
-                <a:latin typeface="Calibri"/>
-                <a:ea typeface="Microsoft YaHei"/>
-                <a:cs typeface="Microsoft YaHei"/>
-              </a:rPr>
-              <a:t>连…都/也 — nhấn mạnh trường hợp cực đoan nhất — 连 + trường hợp cực đoan + 都/也</a:t>
-            </a:r>
-          </a:p>
-          <a:p>
-            <a:pPr>
-              <a:spcBef>
-                <a:spcPts val="400"/>
-              </a:spcBef>
-              <a:buNone/>
-            </a:pPr>
-            <a:r>
-              <a:rPr sz="1700" b="0" i="0">
-                <a:solidFill>
-                  <a:srgbClr val="1F2933"/>
-                </a:solidFill>
-                <a:latin typeface="Calibri"/>
-                <a:ea typeface="Microsoft YaHei"/>
-                <a:cs typeface="Microsoft YaHei"/>
-              </a:rPr>
-              <a:t>   </a:t>
-            </a:r>
-            <a:r>
-              <a:rPr sz="1700" b="0" i="0">
-                <a:solidFill>
-                  <a:srgbClr val="1F2933"/>
-                </a:solidFill>
-                <a:latin typeface="Calibri"/>
-                <a:ea typeface="Microsoft YaHei"/>
-                <a:cs typeface="Microsoft YaHei"/>
-              </a:rPr>
-              <a:t>他忙得连饭不都吃。</a:t>
+              <a:t>'Nhà anh ấy cách nhà tôi rất gần' — A) 他家离我家很近  B) 他家很近离我家  C) 离他家我家很近</a:t>
             </a:r>
           </a:p>
         </p:txBody>
@@ -4682,7 +4653,7 @@
                 <a:ea typeface="Microsoft YaHei"/>
                 <a:cs typeface="Microsoft YaHei"/>
               </a:rPr>
-              <a:t>练习 12/17 · Bài 11</a:t>
+              <a:t>练习 11/17 · Bài 10</a:t>
             </a:r>
           </a:p>
         </p:txBody>
@@ -4721,7 +4692,7 @@
                 <a:ea typeface="Microsoft YaHei"/>
                 <a:cs typeface="Microsoft YaHei"/>
               </a:rPr>
-              <a:t>Dịch nhanh Việt → Trung</a:t>
+              <a:t>Tìm và sửa câu sai</a:t>
             </a:r>
           </a:p>
         </p:txBody>
@@ -4760,7 +4731,7 @@
                 <a:ea typeface="Microsoft YaHei"/>
                 <a:cs typeface="Microsoft YaHei"/>
               </a:rPr>
-              <a:t>Dịch nhanh sang tiếng Trung:</a:t>
+              <a:t>Mỗi câu sau có 1 lỗi — tìm và sửa lại:</a:t>
             </a:r>
           </a:p>
           <a:p>
@@ -4790,7 +4761,7 @@
                 <a:ea typeface="Microsoft YaHei"/>
                 <a:cs typeface="Microsoft YaHei"/>
               </a:rPr>
-              <a:t>着 — hành động/trạng thái đang tiếp diễn — động từ + 着</a:t>
+              <a:t>选择问句 — nối 2 lựa chọn trong câu hỏi — A + 还是 + B</a:t>
             </a:r>
           </a:p>
           <a:p>
@@ -4820,7 +4791,7 @@
                 <a:ea typeface="Microsoft YaHei"/>
                 <a:cs typeface="Microsoft YaHei"/>
               </a:rPr>
-              <a:t>Cửa sổ đang mở.</a:t>
+              <a:t>你想喝茶还是咖啡还是？</a:t>
             </a:r>
           </a:p>
           <a:p>
@@ -4850,7 +4821,7 @@
                 <a:ea typeface="Microsoft YaHei"/>
                 <a:cs typeface="Microsoft YaHei"/>
               </a:rPr>
-              <a:t>最 — mức độ cao nhất — 最 + tính từ</a:t>
+              <a:t>连…都/也 — nhấn mạnh trường hợp cực đoan nhất — 连 + trường hợp cực đoan + 都/也</a:t>
             </a:r>
           </a:p>
           <a:p>
@@ -4880,67 +4851,7 @@
                 <a:ea typeface="Microsoft YaHei"/>
                 <a:cs typeface="Microsoft YaHei"/>
               </a:rPr>
-              <a:t>Trong nhà, bố cao nhất.</a:t>
-            </a:r>
-          </a:p>
-          <a:p>
-            <a:pPr>
-              <a:spcBef>
-                <a:spcPts val="2600"/>
-              </a:spcBef>
-              <a:buNone/>
-            </a:pPr>
-            <a:r>
-              <a:rPr sz="2200" b="1" i="0">
-                <a:solidFill>
-                  <a:srgbClr val="8E2B20"/>
-                </a:solidFill>
-                <a:latin typeface="Calibri"/>
-                <a:ea typeface="Microsoft YaHei"/>
-                <a:cs typeface="Microsoft YaHei"/>
-              </a:rPr>
-              <a:t>3. </a:t>
-            </a:r>
-            <a:r>
-              <a:rPr sz="2200" b="1" i="0">
-                <a:solidFill>
-                  <a:srgbClr val="1F2933"/>
-                </a:solidFill>
-                <a:latin typeface="Calibri"/>
-                <a:ea typeface="Microsoft YaHei"/>
-                <a:cs typeface="Microsoft YaHei"/>
-              </a:rPr>
-              <a:t>被字句 — vật bị/được tác động — vật + 被 + người + động từ</a:t>
-            </a:r>
-          </a:p>
-          <a:p>
-            <a:pPr>
-              <a:spcBef>
-                <a:spcPts val="400"/>
-              </a:spcBef>
-              <a:buNone/>
-            </a:pPr>
-            <a:r>
-              <a:rPr sz="1700" b="0" i="0">
-                <a:solidFill>
-                  <a:srgbClr val="1F2933"/>
-                </a:solidFill>
-                <a:latin typeface="Calibri"/>
-                <a:ea typeface="Microsoft YaHei"/>
-                <a:cs typeface="Microsoft YaHei"/>
-              </a:rPr>
-              <a:t>   </a:t>
-            </a:r>
-            <a:r>
-              <a:rPr sz="1700" b="0" i="0">
-                <a:solidFill>
-                  <a:srgbClr val="1F2933"/>
-                </a:solidFill>
-                <a:latin typeface="Calibri"/>
-                <a:ea typeface="Microsoft YaHei"/>
-                <a:cs typeface="Microsoft YaHei"/>
-              </a:rPr>
-              <a:t>Cái bánh đã bị em trai ăn hết rồi.</a:t>
+              <a:t>他忙得连饭不都吃。</a:t>
             </a:r>
           </a:p>
         </p:txBody>
@@ -5103,7 +5014,7 @@
                 <a:ea typeface="Microsoft YaHei"/>
                 <a:cs typeface="Microsoft YaHei"/>
               </a:rPr>
-              <a:t>练习 13/17 · Bài 13</a:t>
+              <a:t>练习 12/17 · Bài 11</a:t>
             </a:r>
           </a:p>
         </p:txBody>
@@ -5142,7 +5053,7 @@
                 <a:ea typeface="Microsoft YaHei"/>
                 <a:cs typeface="Microsoft YaHei"/>
               </a:rPr>
-              <a:t>Đúng hay Sai?</a:t>
+              <a:t>Dịch nhanh Việt → Trung</a:t>
             </a:r>
           </a:p>
         </p:txBody>
@@ -5181,7 +5092,7 @@
                 <a:ea typeface="Microsoft YaHei"/>
                 <a:cs typeface="Microsoft YaHei"/>
               </a:rPr>
-              <a:t>Câu sau ĐÚNG hay SAI ngữ pháp?</a:t>
+              <a:t>Dịch nhanh sang tiếng Trung:</a:t>
             </a:r>
           </a:p>
           <a:p>
@@ -5211,7 +5122,7 @@
                 <a:ea typeface="Microsoft YaHei"/>
                 <a:cs typeface="Microsoft YaHei"/>
               </a:rPr>
-              <a:t>双宾语句(2) — cho ai cái gì — động từ + 给 + người nhận + vật</a:t>
+              <a:t>着 — hành động/trạng thái đang tiếp diễn — động từ + 着</a:t>
             </a:r>
           </a:p>
           <a:p>
@@ -5241,7 +5152,7 @@
                 <a:ea typeface="Microsoft YaHei"/>
                 <a:cs typeface="Microsoft YaHei"/>
               </a:rPr>
-              <a:t>'他送给我一本书' đúng ngữ pháp.</a:t>
+              <a:t>Cửa sổ đang mở.</a:t>
             </a:r>
           </a:p>
           <a:p>
@@ -5271,7 +5182,97 @@
                 <a:ea typeface="Microsoft YaHei"/>
                 <a:cs typeface="Microsoft YaHei"/>
               </a:rPr>
-              <a:t>'他送我给一本书' đúng ngữ pháp.</a:t>
+              <a:t>最 — mức độ cao nhất — 最 + tính từ</a:t>
+            </a:r>
+          </a:p>
+          <a:p>
+            <a:pPr>
+              <a:spcBef>
+                <a:spcPts val="400"/>
+              </a:spcBef>
+              <a:buNone/>
+            </a:pPr>
+            <a:r>
+              <a:rPr sz="1700" b="0" i="0">
+                <a:solidFill>
+                  <a:srgbClr val="1F2933"/>
+                </a:solidFill>
+                <a:latin typeface="Calibri"/>
+                <a:ea typeface="Microsoft YaHei"/>
+                <a:cs typeface="Microsoft YaHei"/>
+              </a:rPr>
+              <a:t>   </a:t>
+            </a:r>
+            <a:r>
+              <a:rPr sz="1700" b="0" i="0">
+                <a:solidFill>
+                  <a:srgbClr val="1F2933"/>
+                </a:solidFill>
+                <a:latin typeface="Calibri"/>
+                <a:ea typeface="Microsoft YaHei"/>
+                <a:cs typeface="Microsoft YaHei"/>
+              </a:rPr>
+              <a:t>Trong nhà, bố cao nhất.</a:t>
+            </a:r>
+          </a:p>
+          <a:p>
+            <a:pPr>
+              <a:spcBef>
+                <a:spcPts val="2600"/>
+              </a:spcBef>
+              <a:buNone/>
+            </a:pPr>
+            <a:r>
+              <a:rPr sz="2200" b="1" i="0">
+                <a:solidFill>
+                  <a:srgbClr val="8E2B20"/>
+                </a:solidFill>
+                <a:latin typeface="Calibri"/>
+                <a:ea typeface="Microsoft YaHei"/>
+                <a:cs typeface="Microsoft YaHei"/>
+              </a:rPr>
+              <a:t>3. </a:t>
+            </a:r>
+            <a:r>
+              <a:rPr sz="2200" b="1" i="0">
+                <a:solidFill>
+                  <a:srgbClr val="1F2933"/>
+                </a:solidFill>
+                <a:latin typeface="Calibri"/>
+                <a:ea typeface="Microsoft YaHei"/>
+                <a:cs typeface="Microsoft YaHei"/>
+              </a:rPr>
+              <a:t>被字句 — vật bị/được tác động — vật + 被 + người + động từ</a:t>
+            </a:r>
+          </a:p>
+          <a:p>
+            <a:pPr>
+              <a:spcBef>
+                <a:spcPts val="400"/>
+              </a:spcBef>
+              <a:buNone/>
+            </a:pPr>
+            <a:r>
+              <a:rPr sz="1700" b="0" i="0">
+                <a:solidFill>
+                  <a:srgbClr val="1F2933"/>
+                </a:solidFill>
+                <a:latin typeface="Calibri"/>
+                <a:ea typeface="Microsoft YaHei"/>
+                <a:cs typeface="Microsoft YaHei"/>
+              </a:rPr>
+              <a:t>   </a:t>
+            </a:r>
+            <a:r>
+              <a:rPr sz="1700" b="0" i="0">
+                <a:solidFill>
+                  <a:srgbClr val="1F2933"/>
+                </a:solidFill>
+                <a:latin typeface="Calibri"/>
+                <a:ea typeface="Microsoft YaHei"/>
+                <a:cs typeface="Microsoft YaHei"/>
+              </a:rPr>
+              <a:t>Cái bánh đã bị em trai ăn hết rồi.</a:t>
             </a:r>
           </a:p>
         </p:txBody>
@@ -5434,7 +5435,7 @@
                 <a:ea typeface="Microsoft YaHei"/>
                 <a:cs typeface="Microsoft YaHei"/>
               </a:rPr>
-              <a:t>练习 14/17 · Bài 14</a:t>
+              <a:t>练习 13/17 · Bài 13</a:t>
             </a:r>
           </a:p>
         </p:txBody>
@@ -5473,7 +5474,7 @@
                 <a:ea typeface="Microsoft YaHei"/>
                 <a:cs typeface="Microsoft YaHei"/>
               </a:rPr>
-              <a:t>Điền từ vào chỗ trống</a:t>
+              <a:t>Đúng hay Sai?</a:t>
             </a:r>
           </a:p>
         </p:txBody>
@@ -5512,7 +5513,7 @@
                 <a:ea typeface="Microsoft YaHei"/>
                 <a:cs typeface="Microsoft YaHei"/>
               </a:rPr>
-              <a:t>Điền chữ còn thiếu:</a:t>
+              <a:t>Câu sau ĐÚNG hay SAI ngữ pháp?</a:t>
             </a:r>
           </a:p>
           <a:p>
@@ -5542,7 +5543,7 @@
                 <a:ea typeface="Microsoft YaHei"/>
                 <a:cs typeface="Microsoft YaHei"/>
               </a:rPr>
-              <a:t>存现句(2) — nơi chốn có ai/gì xuất hiện — nơi chốn + động từ + 着 + người/vật</a:t>
+              <a:t>双宾语句(2) — cho ai cái gì — động từ + 给 + người nhận + vật</a:t>
             </a:r>
           </a:p>
           <a:p>
@@ -5572,7 +5573,7 @@
                 <a:ea typeface="Microsoft YaHei"/>
                 <a:cs typeface="Microsoft YaHei"/>
               </a:rPr>
-              <a:t>墙上挂 ___ 一张照片。</a:t>
+              <a:t>'他送给我一本书' đúng ngữ pháp.</a:t>
             </a:r>
           </a:p>
           <a:p>
@@ -5602,37 +5603,7 @@
                 <a:ea typeface="Microsoft YaHei"/>
                 <a:cs typeface="Microsoft YaHei"/>
               </a:rPr>
-              <a:t>多(cảm thán) — câu cảm thán, mức độ rất cao — 多 + tính từ + 啊</a:t>
-            </a:r>
-          </a:p>
-          <a:p>
-            <a:pPr>
-              <a:spcBef>
-                <a:spcPts val="400"/>
-              </a:spcBef>
-              <a:buNone/>
-            </a:pPr>
-            <a:r>
-              <a:rPr sz="1700" b="0" i="0">
-                <a:solidFill>
-                  <a:srgbClr val="1F2933"/>
-                </a:solidFill>
-                <a:latin typeface="Calibri"/>
-                <a:ea typeface="Microsoft YaHei"/>
-                <a:cs typeface="Microsoft YaHei"/>
-              </a:rPr>
-              <a:t>   </a:t>
-            </a:r>
-            <a:r>
-              <a:rPr sz="1700" b="0" i="0">
-                <a:solidFill>
-                  <a:srgbClr val="1F2933"/>
-                </a:solidFill>
-                <a:latin typeface="Calibri"/>
-                <a:ea typeface="Microsoft YaHei"/>
-                <a:cs typeface="Microsoft YaHei"/>
-              </a:rPr>
-              <a:t>今天天气多 ___ 啊！</a:t>
+              <a:t>'他送我给一本书' đúng ngữ pháp.</a:t>
             </a:r>
           </a:p>
         </p:txBody>
@@ -5795,7 +5766,7 @@
                 <a:ea typeface="Microsoft YaHei"/>
                 <a:cs typeface="Microsoft YaHei"/>
               </a:rPr>
-              <a:t>练习 15/17 · Bài 14</a:t>
+              <a:t>练习 14/17 · Bài 14</a:t>
             </a:r>
           </a:p>
         </p:txBody>
@@ -5834,7 +5805,7 @@
                 <a:ea typeface="Microsoft YaHei"/>
                 <a:cs typeface="Microsoft YaHei"/>
               </a:rPr>
-              <a:t>Trắc nghiệm chọn câu đúng</a:t>
+              <a:t>Điền từ vào chỗ trống</a:t>
             </a:r>
           </a:p>
         </p:txBody>
@@ -5873,7 +5844,7 @@
                 <a:ea typeface="Microsoft YaHei"/>
                 <a:cs typeface="Microsoft YaHei"/>
               </a:rPr>
-              <a:t>Chọn câu ĐÚNG cho ý sau (làm nhiều hơn, KHÔNG phải cảm thán):</a:t>
+              <a:t>Điền chữ còn thiếu:</a:t>
             </a:r>
           </a:p>
           <a:p>
@@ -5903,7 +5874,7 @@
                 <a:ea typeface="Microsoft YaHei"/>
                 <a:cs typeface="Microsoft YaHei"/>
               </a:rPr>
-              <a:t>副词「多」+ động từ — làm nhiều hơn — 多 + động từ</a:t>
+              <a:t>存现句(2) — nơi chốn có ai/gì xuất hiện — nơi chốn + động từ + 着 + người/vật</a:t>
             </a:r>
           </a:p>
           <a:p>
@@ -5933,7 +5904,67 @@
                 <a:ea typeface="Microsoft YaHei"/>
                 <a:cs typeface="Microsoft YaHei"/>
               </a:rPr>
-              <a:t>'Trời lạnh rồi, hãy mặc thêm quần áo vào' — A) 天冷了，多穿点衣服！  B) 天冷了，穿多点衣服！  C) 天冷了，衣服多穿点！</a:t>
+              <a:t>墙上挂 ___ 一张照片。</a:t>
+            </a:r>
+          </a:p>
+          <a:p>
+            <a:pPr>
+              <a:spcBef>
+                <a:spcPts val="2600"/>
+              </a:spcBef>
+              <a:buNone/>
+            </a:pPr>
+            <a:r>
+              <a:rPr sz="2200" b="1" i="0">
+                <a:solidFill>
+                  <a:srgbClr val="8E2B20"/>
+                </a:solidFill>
+                <a:latin typeface="Calibri"/>
+                <a:ea typeface="Microsoft YaHei"/>
+                <a:cs typeface="Microsoft YaHei"/>
+              </a:rPr>
+              <a:t>2. </a:t>
+            </a:r>
+            <a:r>
+              <a:rPr sz="2200" b="1" i="0">
+                <a:solidFill>
+                  <a:srgbClr val="1F2933"/>
+                </a:solidFill>
+                <a:latin typeface="Calibri"/>
+                <a:ea typeface="Microsoft YaHei"/>
+                <a:cs typeface="Microsoft YaHei"/>
+              </a:rPr>
+              <a:t>多(cảm thán) — câu cảm thán, mức độ rất cao — 多 + tính từ + 啊</a:t>
+            </a:r>
+          </a:p>
+          <a:p>
+            <a:pPr>
+              <a:spcBef>
+                <a:spcPts val="400"/>
+              </a:spcBef>
+              <a:buNone/>
+            </a:pPr>
+            <a:r>
+              <a:rPr sz="1700" b="0" i="0">
+                <a:solidFill>
+                  <a:srgbClr val="1F2933"/>
+                </a:solidFill>
+                <a:latin typeface="Calibri"/>
+                <a:ea typeface="Microsoft YaHei"/>
+                <a:cs typeface="Microsoft YaHei"/>
+              </a:rPr>
+              <a:t>   </a:t>
+            </a:r>
+            <a:r>
+              <a:rPr sz="1700" b="0" i="0">
+                <a:solidFill>
+                  <a:srgbClr val="1F2933"/>
+                </a:solidFill>
+                <a:latin typeface="Calibri"/>
+                <a:ea typeface="Microsoft YaHei"/>
+                <a:cs typeface="Microsoft YaHei"/>
+              </a:rPr>
+              <a:t>今天天气多 ___ 啊！</a:t>
             </a:r>
           </a:p>
         </p:txBody>
@@ -6053,7 +6084,7 @@
         <p:spPr>
           <a:xfrm>
             <a:off x="548640" y="146304"/>
-            <a:ext cx="3159434" cy="384048"/>
+            <a:ext cx="2585923" cy="384048"/>
           </a:xfrm>
           <a:prstGeom prst="roundRect">
             <a:avLst/>
@@ -6096,7 +6127,7 @@
                 <a:ea typeface="Microsoft YaHei"/>
                 <a:cs typeface="Microsoft YaHei"/>
               </a:rPr>
-              <a:t>练习 16/17 · Bài 14 拓展</a:t>
+              <a:t>练习 15/17 · Bài 14</a:t>
             </a:r>
           </a:p>
         </p:txBody>
@@ -6135,7 +6166,7 @@
                 <a:ea typeface="Microsoft YaHei"/>
                 <a:cs typeface="Microsoft YaHei"/>
               </a:rPr>
-              <a:t>Sắp xếp thành câu đúng</a:t>
+              <a:t>Trắc nghiệm chọn câu đúng</a:t>
             </a:r>
           </a:p>
         </p:txBody>
@@ -6174,7 +6205,7 @@
                 <a:ea typeface="Microsoft YaHei"/>
                 <a:cs typeface="Microsoft YaHei"/>
               </a:rPr>
-              <a:t>Sắp xếp thành câu đúng:</a:t>
+              <a:t>Chọn câu ĐÚNG cho ý sau (làm nhiều hơn, KHÔNG phải cảm thán):</a:t>
             </a:r>
           </a:p>
           <a:p>
@@ -6204,7 +6235,7 @@
                 <a:ea typeface="Microsoft YaHei"/>
                 <a:cs typeface="Microsoft YaHei"/>
               </a:rPr>
-              <a:t>已经…没…了 — đã lâu không làm gì — 已经 + thời gian + 没 + động từ + 了</a:t>
+              <a:t>副词「多」+ động từ — làm nhiều hơn — 多 + động từ</a:t>
             </a:r>
           </a:p>
           <a:p>
@@ -6234,37 +6265,7 @@
                 <a:ea typeface="Microsoft YaHei"/>
                 <a:cs typeface="Microsoft YaHei"/>
               </a:rPr>
-              <a:t>了 / 我 / 两 / 年 / 没 / 已经 / 回国</a:t>
-            </a:r>
-          </a:p>
-          <a:p>
-            <a:pPr>
-              <a:spcBef>
-                <a:spcPts val="2600"/>
-              </a:spcBef>
-              <a:buNone/>
-            </a:pPr>
-            <a:r>
-              <a:rPr sz="2200" b="1" i="0">
-                <a:solidFill>
-                  <a:srgbClr val="8E2B20"/>
-                </a:solidFill>
-                <a:latin typeface="Calibri"/>
-                <a:ea typeface="Microsoft YaHei"/>
-                <a:cs typeface="Microsoft YaHei"/>
-              </a:rPr>
-              <a:t>2. </a:t>
-            </a:r>
-            <a:r>
-              <a:rPr sz="2200" b="1" i="0">
-                <a:solidFill>
-                  <a:srgbClr val="1F2933"/>
-                </a:solidFill>
-                <a:latin typeface="Calibri"/>
-                <a:ea typeface="Microsoft YaHei"/>
-                <a:cs typeface="Microsoft YaHei"/>
-              </a:rPr>
-              <a:t>我们 / 上 / 了 / 爱 / 中文课</a:t>
+              <a:t>'Trời lạnh rồi, hãy mặc thêm quần áo vào' — A) 天冷了，多穿点衣服！  B) 天冷了，穿多点衣服！  C) 天冷了，衣服多穿点！</a:t>
             </a:r>
           </a:p>
         </p:txBody>
@@ -6384,7 +6385,7 @@
         <p:spPr>
           <a:xfrm>
             <a:off x="548640" y="146304"/>
-            <a:ext cx="2585923" cy="384048"/>
+            <a:ext cx="3159434" cy="384048"/>
           </a:xfrm>
           <a:prstGeom prst="roundRect">
             <a:avLst/>
@@ -6427,7 +6428,7 @@
                 <a:ea typeface="Microsoft YaHei"/>
                 <a:cs typeface="Microsoft YaHei"/>
               </a:rPr>
-              <a:t>练习 17/17 · Bài 15</a:t>
+              <a:t>练习 16/17 · Bài 14 拓展</a:t>
             </a:r>
           </a:p>
         </p:txBody>
@@ -6466,7 +6467,7 @@
                 <a:ea typeface="Microsoft YaHei"/>
                 <a:cs typeface="Microsoft YaHei"/>
               </a:rPr>
-              <a:t>Trắc nghiệm chọn câu đúng</a:t>
+              <a:t>Sắp xếp thành câu đúng</a:t>
             </a:r>
           </a:p>
         </p:txBody>
@@ -6505,7 +6506,7 @@
                 <a:ea typeface="Microsoft YaHei"/>
                 <a:cs typeface="Microsoft YaHei"/>
               </a:rPr>
-              <a:t>Chọn câu ĐÚNG cho ý sau:</a:t>
+              <a:t>Sắp xếp thành câu đúng:</a:t>
             </a:r>
           </a:p>
           <a:p>
@@ -6535,7 +6536,7 @@
                 <a:ea typeface="Microsoft YaHei"/>
                 <a:cs typeface="Microsoft YaHei"/>
               </a:rPr>
-              <a:t>有字句(2) — đạt tới mức độ nào đó — 有 + số lượng</a:t>
+              <a:t>已经…没…了 — đã lâu không làm gì — 已经 + thời gian + 没 + động từ + 了</a:t>
             </a:r>
           </a:p>
           <a:p>
@@ -6565,7 +6566,37 @@
                 <a:ea typeface="Microsoft YaHei"/>
                 <a:cs typeface="Microsoft YaHei"/>
               </a:rPr>
-              <a:t>'Đã nửa năm rồi không gặp' — A) 我们有半年没见了  B) 我们没半年有见了  C) 我们半年有没见了</a:t>
+              <a:t>了 / 我 / 两 / 年 / 没 / 已经 / 回国</a:t>
+            </a:r>
+          </a:p>
+          <a:p>
+            <a:pPr>
+              <a:spcBef>
+                <a:spcPts val="2600"/>
+              </a:spcBef>
+              <a:buNone/>
+            </a:pPr>
+            <a:r>
+              <a:rPr sz="2200" b="1" i="0">
+                <a:solidFill>
+                  <a:srgbClr val="8E2B20"/>
+                </a:solidFill>
+                <a:latin typeface="Calibri"/>
+                <a:ea typeface="Microsoft YaHei"/>
+                <a:cs typeface="Microsoft YaHei"/>
+              </a:rPr>
+              <a:t>2. </a:t>
+            </a:r>
+            <a:r>
+              <a:rPr sz="2200" b="1" i="0">
+                <a:solidFill>
+                  <a:srgbClr val="1F2933"/>
+                </a:solidFill>
+                <a:latin typeface="Calibri"/>
+                <a:ea typeface="Microsoft YaHei"/>
+                <a:cs typeface="Microsoft YaHei"/>
+              </a:rPr>
+              <a:t>我们 / 上 / 了 / 爱 / 中文课</a:t>
             </a:r>
           </a:p>
         </p:txBody>
@@ -6641,7 +6672,7 @@
         <p:spPr>
           <a:xfrm>
             <a:off x="0" y="0"/>
-            <a:ext cx="12191695" cy="1337056"/>
+            <a:ext cx="12191695" cy="1775968"/>
           </a:xfrm>
           <a:prstGeom prst="rect">
             <a:avLst/>
@@ -6728,7 +6759,7 @@
                 <a:ea typeface="Microsoft YaHei"/>
                 <a:cs typeface="Microsoft YaHei"/>
               </a:rPr>
-              <a:t>目标</a:t>
+              <a:t>口语热身</a:t>
             </a:r>
           </a:p>
         </p:txBody>
@@ -6742,7 +6773,7 @@
         <p:spPr>
           <a:xfrm>
             <a:off x="548640" y="566928"/>
-            <a:ext cx="11094415" cy="642112"/>
+            <a:ext cx="11094415" cy="1081024"/>
           </a:xfrm>
           <a:prstGeom prst="rect">
             <a:avLst/>
@@ -6767,7 +6798,7 @@
                 <a:ea typeface="Microsoft YaHei"/>
                 <a:cs typeface="Microsoft YaHei"/>
               </a:rPr>
-              <a:t>Mục tiêu buổi ôn</a:t>
+              <a:t>Khởi động: trả lời 2 câu hỏi trước khi vào bài</a:t>
             </a:r>
           </a:p>
         </p:txBody>
@@ -6780,8 +6811,8 @@
         </p:nvSpPr>
         <p:spPr>
           <a:xfrm>
-            <a:off x="548640" y="1611376"/>
-            <a:ext cx="11094415" cy="4880864"/>
+            <a:off x="548640" y="2050288"/>
+            <a:ext cx="11094415" cy="4441952"/>
           </a:xfrm>
           <a:prstGeom prst="rect">
             <a:avLst/>
@@ -6820,7 +6851,37 @@
                 <a:ea typeface="Microsoft YaHei"/>
                 <a:cs typeface="Microsoft YaHei"/>
               </a:rPr>
-              <a:t>Mỗi điểm ngữ pháp: 1 dòng [ngữ pháp — mục đích — cách dùng] rồi tới bài tập kiểm tra ngay</a:t>
+              <a:t>请介绍一下你最喜欢的一个节日。</a:t>
+            </a:r>
+          </a:p>
+          <a:p>
+            <a:pPr>
+              <a:spcBef>
+                <a:spcPts val="400"/>
+              </a:spcBef>
+              <a:buNone/>
+            </a:pPr>
+            <a:r>
+              <a:rPr sz="1700" b="0" i="0">
+                <a:solidFill>
+                  <a:srgbClr val="1F2933"/>
+                </a:solidFill>
+                <a:latin typeface="Calibri"/>
+                <a:ea typeface="Microsoft YaHei"/>
+                <a:cs typeface="Microsoft YaHei"/>
+              </a:rPr>
+              <a:t>   </a:t>
+            </a:r>
+            <a:r>
+              <a:rPr sz="1700" b="0" i="0">
+                <a:solidFill>
+                  <a:srgbClr val="1F2933"/>
+                </a:solidFill>
+                <a:latin typeface="Calibri"/>
+                <a:ea typeface="Microsoft YaHei"/>
+                <a:cs typeface="Microsoft YaHei"/>
+              </a:rPr>
+              <a:t>开头: Đó là lễ gì? Bạn thường làm gì vào dịp đó? — 主体: Vì sao bạn thích lễ đó? — 结尾: Bạn mong chờ điều gì nhất ở lễ đó?</a:t>
             </a:r>
           </a:p>
           <a:p>
@@ -6850,29 +6911,18 @@
                 <a:ea typeface="Microsoft YaHei"/>
                 <a:cs typeface="Microsoft YaHei"/>
               </a:rPr>
-              <a:t>Mỗi nhóm 1 dạng bài tập khác nhau: sắp xếp câu, điền từ, trắc nghiệm, tìm lỗi sai, dịch nhanh, đúng/sai</a:t>
+              <a:t>你觉得学开车难不难？为什么？</a:t>
             </a:r>
           </a:p>
           <a:p>
             <a:pPr>
               <a:spcBef>
-                <a:spcPts val="2600"/>
+                <a:spcPts val="400"/>
               </a:spcBef>
               <a:buNone/>
             </a:pPr>
             <a:r>
-              <a:rPr sz="2200" b="1" i="0">
-                <a:solidFill>
-                  <a:srgbClr val="8E2B20"/>
-                </a:solidFill>
-                <a:latin typeface="Calibri"/>
-                <a:ea typeface="Microsoft YaHei"/>
-                <a:cs typeface="Microsoft YaHei"/>
-              </a:rPr>
-              <a:t>•  </a:t>
-            </a:r>
-            <a:r>
-              <a:rPr sz="2200" b="1" i="0">
+              <a:rPr sz="1700" b="0" i="0">
                 <a:solidFill>
                   <a:srgbClr val="1F2933"/>
                 </a:solidFill>
@@ -6880,29 +6930,10 @@
                 <a:ea typeface="Microsoft YaHei"/>
                 <a:cs typeface="Microsoft YaHei"/>
               </a:rPr>
-              <a:t>Một số câu bài tập lấy TRỰC TIẾP từ đề thi 官方样卷 HSK2 (đánh dấu 【官方样卷】)</a:t>
-            </a:r>
-          </a:p>
-          <a:p>
-            <a:pPr>
-              <a:spcBef>
-                <a:spcPts val="2600"/>
-              </a:spcBef>
-              <a:buNone/>
-            </a:pPr>
-            <a:r>
-              <a:rPr sz="2200" b="1" i="0">
-                <a:solidFill>
-                  <a:srgbClr val="8E2B20"/>
-                </a:solidFill>
-                <a:latin typeface="Calibri"/>
-                <a:ea typeface="Microsoft YaHei"/>
-                <a:cs typeface="Microsoft YaHei"/>
-              </a:rPr>
-              <a:t>•  </a:t>
-            </a:r>
-            <a:r>
-              <a:rPr sz="2200" b="1" i="0">
+              <a:t>   </a:t>
+            </a:r>
+            <a:r>
+              <a:rPr sz="1700" b="0" i="0">
                 <a:solidFill>
                   <a:srgbClr val="1F2933"/>
                 </a:solidFill>
@@ -6910,7 +6941,7 @@
                 <a:ea typeface="Microsoft YaHei"/>
                 <a:cs typeface="Microsoft YaHei"/>
               </a:rPr>
-              <a:t>Không học nội dung mới — chỉ ôn tập và luyện phản xạ</a:t>
+              <a:t>开头: Bạn thấy học lái xe khó hay dễ? — 主体: Vì sao bạn nghĩ vậy? — 结尾: Bạn có muốn học lái xe không?</a:t>
             </a:r>
           </a:p>
         </p:txBody>
@@ -6924,6 +6955,307 @@
 </file>
 
 <file path=ppt/slides/slide20.xml><?xml version="1.0" encoding="utf-8"?>
+<p:sld xmlns:a="http://schemas.openxmlformats.org/drawingml/2006/main" xmlns:p="http://schemas.openxmlformats.org/presentationml/2006/main" xmlns:r="http://schemas.openxmlformats.org/officeDocument/2006/relationships">
+  <p:cSld>
+    <p:spTree>
+      <p:nvGrpSpPr>
+        <p:cNvPr id="1" name=""/>
+        <p:cNvGrpSpPr/>
+        <p:nvPr/>
+      </p:nvGrpSpPr>
+      <p:grpSpPr/>
+      <p:sp>
+        <p:nvSpPr>
+          <p:cNvPr id="2" name="Rectangle 1"/>
+          <p:cNvSpPr/>
+          <p:nvPr/>
+        </p:nvSpPr>
+        <p:spPr>
+          <a:xfrm>
+            <a:off x="0" y="0"/>
+            <a:ext cx="12191695" cy="6858000"/>
+          </a:xfrm>
+          <a:prstGeom prst="rect">
+            <a:avLst/>
+          </a:prstGeom>
+          <a:solidFill>
+            <a:srgbClr val="FFFFFF"/>
+          </a:solidFill>
+          <a:ln>
+            <a:noFill/>
+          </a:ln>
+          <a:effectLst/>
+        </p:spPr>
+        <p:style>
+          <a:lnRef idx="1">
+            <a:schemeClr val="accent1"/>
+          </a:lnRef>
+          <a:fillRef idx="3">
+            <a:schemeClr val="accent1"/>
+          </a:fillRef>
+          <a:effectRef idx="2">
+            <a:schemeClr val="accent1"/>
+          </a:effectRef>
+          <a:fontRef idx="minor">
+            <a:schemeClr val="lt1"/>
+          </a:fontRef>
+        </p:style>
+        <p:txBody>
+          <a:bodyPr rtlCol="0" anchor="ctr"/>
+          <a:lstStyle/>
+          <a:p>
+            <a:pPr algn="ctr"/>
+          </a:p>
+        </p:txBody>
+      </p:sp>
+      <p:sp>
+        <p:nvSpPr>
+          <p:cNvPr id="3" name="Rectangle 2"/>
+          <p:cNvSpPr/>
+          <p:nvPr/>
+        </p:nvSpPr>
+        <p:spPr>
+          <a:xfrm>
+            <a:off x="0" y="0"/>
+            <a:ext cx="12191695" cy="1337056"/>
+          </a:xfrm>
+          <a:prstGeom prst="rect">
+            <a:avLst/>
+          </a:prstGeom>
+          <a:solidFill>
+            <a:srgbClr val="8E2B20"/>
+          </a:solidFill>
+          <a:ln>
+            <a:noFill/>
+          </a:ln>
+          <a:effectLst/>
+        </p:spPr>
+        <p:style>
+          <a:lnRef idx="1">
+            <a:schemeClr val="accent1"/>
+          </a:lnRef>
+          <a:fillRef idx="3">
+            <a:schemeClr val="accent1"/>
+          </a:fillRef>
+          <a:effectRef idx="2">
+            <a:schemeClr val="accent1"/>
+          </a:effectRef>
+          <a:fontRef idx="minor">
+            <a:schemeClr val="lt1"/>
+          </a:fontRef>
+        </p:style>
+        <p:txBody>
+          <a:bodyPr rtlCol="0" anchor="ctr"/>
+          <a:lstStyle/>
+          <a:p>
+            <a:pPr algn="ctr"/>
+          </a:p>
+        </p:txBody>
+      </p:sp>
+      <p:sp>
+        <p:nvSpPr>
+          <p:cNvPr id="4" name="Rounded Rectangle 3"/>
+          <p:cNvSpPr/>
+          <p:nvPr/>
+        </p:nvSpPr>
+        <p:spPr>
+          <a:xfrm>
+            <a:off x="548640" y="146304"/>
+            <a:ext cx="2585923" cy="384048"/>
+          </a:xfrm>
+          <a:prstGeom prst="roundRect">
+            <a:avLst/>
+          </a:prstGeom>
+          <a:solidFill>
+            <a:srgbClr val="5F160D"/>
+          </a:solidFill>
+          <a:ln>
+            <a:noFill/>
+          </a:ln>
+          <a:effectLst/>
+        </p:spPr>
+        <p:style>
+          <a:lnRef idx="1">
+            <a:schemeClr val="accent1"/>
+          </a:lnRef>
+          <a:fillRef idx="3">
+            <a:schemeClr val="accent1"/>
+          </a:fillRef>
+          <a:effectRef idx="2">
+            <a:schemeClr val="accent1"/>
+          </a:effectRef>
+          <a:fontRef idx="minor">
+            <a:schemeClr val="lt1"/>
+          </a:fontRef>
+        </p:style>
+        <p:txBody>
+          <a:bodyPr rtlCol="0" anchor="ctr" wrap="none" tIns="25400" bIns="25400"/>
+          <a:lstStyle/>
+          <a:p>
+            <a:pPr algn="ctr">
+              <a:buNone/>
+            </a:pPr>
+            <a:r>
+              <a:rPr sz="1600" b="1" i="0">
+                <a:solidFill>
+                  <a:srgbClr val="FFFFFF"/>
+                </a:solidFill>
+                <a:latin typeface="Calibri"/>
+                <a:ea typeface="Microsoft YaHei"/>
+                <a:cs typeface="Microsoft YaHei"/>
+              </a:rPr>
+              <a:t>练习 17/17 · Bài 15</a:t>
+            </a:r>
+          </a:p>
+        </p:txBody>
+      </p:sp>
+      <p:sp>
+        <p:nvSpPr>
+          <p:cNvPr id="5" name="TextBox 4"/>
+          <p:cNvSpPr txBox="1"/>
+          <p:nvPr/>
+        </p:nvSpPr>
+        <p:spPr>
+          <a:xfrm>
+            <a:off x="548640" y="566928"/>
+            <a:ext cx="11094415" cy="642112"/>
+          </a:xfrm>
+          <a:prstGeom prst="rect">
+            <a:avLst/>
+          </a:prstGeom>
+          <a:noFill/>
+        </p:spPr>
+        <p:txBody>
+          <a:bodyPr wrap="square" anchor="ctr">
+            <a:spAutoFit/>
+          </a:bodyPr>
+          <a:lstStyle/>
+          <a:p>
+            <a:pPr>
+              <a:buNone/>
+            </a:pPr>
+            <a:r>
+              <a:rPr sz="2700" b="1" i="0">
+                <a:solidFill>
+                  <a:srgbClr val="FFFFFF"/>
+                </a:solidFill>
+                <a:latin typeface="Calibri"/>
+                <a:ea typeface="Microsoft YaHei"/>
+                <a:cs typeface="Microsoft YaHei"/>
+              </a:rPr>
+              <a:t>Trắc nghiệm chọn câu đúng</a:t>
+            </a:r>
+          </a:p>
+        </p:txBody>
+      </p:sp>
+      <p:sp>
+        <p:nvSpPr>
+          <p:cNvPr id="6" name="TextBox 5"/>
+          <p:cNvSpPr txBox="1"/>
+          <p:nvPr/>
+        </p:nvSpPr>
+        <p:spPr>
+          <a:xfrm>
+            <a:off x="548640" y="1611376"/>
+            <a:ext cx="11094415" cy="4880864"/>
+          </a:xfrm>
+          <a:prstGeom prst="rect">
+            <a:avLst/>
+          </a:prstGeom>
+          <a:noFill/>
+        </p:spPr>
+        <p:txBody>
+          <a:bodyPr wrap="square" anchor="ctr">
+            <a:spAutoFit/>
+          </a:bodyPr>
+          <a:lstStyle/>
+          <a:p>
+            <a:pPr>
+              <a:buNone/>
+            </a:pPr>
+            <a:r>
+              <a:rPr sz="1600" b="0" i="1">
+                <a:solidFill>
+                  <a:srgbClr val="8E2B20"/>
+                </a:solidFill>
+                <a:latin typeface="Calibri"/>
+                <a:ea typeface="Microsoft YaHei"/>
+                <a:cs typeface="Microsoft YaHei"/>
+              </a:rPr>
+              <a:t>Chọn câu ĐÚNG cho ý sau:</a:t>
+            </a:r>
+          </a:p>
+          <a:p>
+            <a:pPr>
+              <a:spcBef>
+                <a:spcPts val="2600"/>
+              </a:spcBef>
+              <a:buNone/>
+            </a:pPr>
+            <a:r>
+              <a:rPr sz="2200" b="1" i="0">
+                <a:solidFill>
+                  <a:srgbClr val="8E2B20"/>
+                </a:solidFill>
+                <a:latin typeface="Calibri"/>
+                <a:ea typeface="Microsoft YaHei"/>
+                <a:cs typeface="Microsoft YaHei"/>
+              </a:rPr>
+              <a:t>1. </a:t>
+            </a:r>
+            <a:r>
+              <a:rPr sz="2200" b="1" i="0">
+                <a:solidFill>
+                  <a:srgbClr val="1F2933"/>
+                </a:solidFill>
+                <a:latin typeface="Calibri"/>
+                <a:ea typeface="Microsoft YaHei"/>
+                <a:cs typeface="Microsoft YaHei"/>
+              </a:rPr>
+              <a:t>有字句(2) — đạt tới mức độ nào đó — 有 + số lượng</a:t>
+            </a:r>
+          </a:p>
+          <a:p>
+            <a:pPr>
+              <a:spcBef>
+                <a:spcPts val="400"/>
+              </a:spcBef>
+              <a:buNone/>
+            </a:pPr>
+            <a:r>
+              <a:rPr sz="1700" b="0" i="0">
+                <a:solidFill>
+                  <a:srgbClr val="1F2933"/>
+                </a:solidFill>
+                <a:latin typeface="Calibri"/>
+                <a:ea typeface="Microsoft YaHei"/>
+                <a:cs typeface="Microsoft YaHei"/>
+              </a:rPr>
+              <a:t>   </a:t>
+            </a:r>
+            <a:r>
+              <a:rPr sz="1700" b="0" i="0">
+                <a:solidFill>
+                  <a:srgbClr val="1F2933"/>
+                </a:solidFill>
+                <a:latin typeface="Calibri"/>
+                <a:ea typeface="Microsoft YaHei"/>
+                <a:cs typeface="Microsoft YaHei"/>
+              </a:rPr>
+              <a:t>'Đã nửa năm rồi không gặp' — A) 我们有半年没见了  B) 我们没半年有见了  C) 我们半年有没见了</a:t>
+            </a:r>
+          </a:p>
+        </p:txBody>
+      </p:sp>
+    </p:spTree>
+  </p:cSld>
+  <p:clrMapOvr>
+    <a:masterClrMapping/>
+  </p:clrMapOvr>
+</p:sld>
+</file>
+
+<file path=ppt/slides/slide21.xml><?xml version="1.0" encoding="utf-8"?>
 <p:sld xmlns:a="http://schemas.openxmlformats.org/drawingml/2006/main" xmlns:p="http://schemas.openxmlformats.org/presentationml/2006/main" xmlns:r="http://schemas.openxmlformats.org/officeDocument/2006/relationships">
   <p:cSld>
     <p:spTree>
@@ -7959,8 +8291,8 @@
         </p:nvSpPr>
         <p:spPr>
           <a:xfrm>
-            <a:off x="548640" y="6473952"/>
-            <a:ext cx="11094415" cy="292608"/>
+            <a:off x="548640" y="6492240"/>
+            <a:ext cx="11094415" cy="274320"/>
           </a:xfrm>
           <a:prstGeom prst="rect">
             <a:avLst/>
@@ -8020,7 +8352,7 @@
 </p:sld>
 </file>
 
-<file path=ppt/slides/slide21.xml><?xml version="1.0" encoding="utf-8"?>
+<file path=ppt/slides/slide22.xml><?xml version="1.0" encoding="utf-8"?>
 <p:sld xmlns:a="http://schemas.openxmlformats.org/drawingml/2006/main" xmlns:p="http://schemas.openxmlformats.org/presentationml/2006/main" xmlns:r="http://schemas.openxmlformats.org/officeDocument/2006/relationships">
   <p:cSld>
     <p:spTree>
@@ -9276,8 +9608,8 @@
         </p:nvSpPr>
         <p:spPr>
           <a:xfrm>
-            <a:off x="548640" y="6473952"/>
-            <a:ext cx="11094415" cy="292608"/>
+            <a:off x="548640" y="6492240"/>
+            <a:ext cx="11094415" cy="274320"/>
           </a:xfrm>
           <a:prstGeom prst="rect">
             <a:avLst/>
@@ -9337,7 +9669,7 @@
 </p:sld>
 </file>
 
-<file path=ppt/slides/slide22.xml><?xml version="1.0" encoding="utf-8"?>
+<file path=ppt/slides/slide23.xml><?xml version="1.0" encoding="utf-8"?>
 <p:sld xmlns:a="http://schemas.openxmlformats.org/drawingml/2006/main" xmlns:p="http://schemas.openxmlformats.org/presentationml/2006/main" xmlns:r="http://schemas.openxmlformats.org/officeDocument/2006/relationships">
   <p:cSld>
     <p:spTree>
@@ -9564,7 +9896,7 @@
         <p:spPr>
           <a:xfrm>
             <a:off x="548640" y="146304"/>
-            <a:ext cx="2349235" cy="384048"/>
+            <a:ext cx="1371600" cy="384048"/>
           </a:xfrm>
           <a:prstGeom prst="roundRect">
             <a:avLst/>
@@ -9607,7 +9939,7 @@
                 <a:ea typeface="Microsoft YaHei"/>
                 <a:cs typeface="Microsoft YaHei"/>
               </a:rPr>
-              <a:t>练习 1/17 · Bài 1</a:t>
+              <a:t>目标</a:t>
             </a:r>
           </a:p>
         </p:txBody>
@@ -9646,7 +9978,7 @@
                 <a:ea typeface="Microsoft YaHei"/>
                 <a:cs typeface="Microsoft YaHei"/>
               </a:rPr>
-              <a:t>Sắp xếp thành câu đúng</a:t>
+              <a:t>Mục tiêu buổi ôn</a:t>
             </a:r>
           </a:p>
         </p:txBody>
@@ -9674,10 +10006,13 @@
           <a:lstStyle/>
           <a:p>
             <a:pPr>
-              <a:buNone/>
-            </a:pPr>
-            <a:r>
-              <a:rPr sz="1600" b="0" i="1">
+              <a:spcBef>
+                <a:spcPts val="2600"/>
+              </a:spcBef>
+              <a:buNone/>
+            </a:pPr>
+            <a:r>
+              <a:rPr sz="2200" b="1" i="0">
                 <a:solidFill>
                   <a:srgbClr val="8E2B20"/>
                 </a:solidFill>
@@ -9685,7 +10020,18 @@
                 <a:ea typeface="Microsoft YaHei"/>
                 <a:cs typeface="Microsoft YaHei"/>
               </a:rPr>
-              <a:t>Sắp xếp các từ sau thành câu đúng:</a:t>
+              <a:t>•  </a:t>
+            </a:r>
+            <a:r>
+              <a:rPr sz="2200" b="1" i="0">
+                <a:solidFill>
+                  <a:srgbClr val="1F2933"/>
+                </a:solidFill>
+                <a:latin typeface="Calibri"/>
+                <a:ea typeface="Microsoft YaHei"/>
+                <a:cs typeface="Microsoft YaHei"/>
+              </a:rPr>
+              <a:t>Mỗi điểm ngữ pháp: 1 dòng [ngữ pháp — mục đích — cách dùng] rồi tới bài tập kiểm tra ngay</a:t>
             </a:r>
           </a:p>
           <a:p>
@@ -9704,7 +10050,7 @@
                 <a:ea typeface="Microsoft YaHei"/>
                 <a:cs typeface="Microsoft YaHei"/>
               </a:rPr>
-              <a:t>1. </a:t>
+              <a:t>•  </a:t>
             </a:r>
             <a:r>
               <a:rPr sz="2200" b="1" i="0">
@@ -9715,37 +10061,7 @@
                 <a:ea typeface="Microsoft YaHei"/>
                 <a:cs typeface="Microsoft YaHei"/>
               </a:rPr>
-              <a:t>吧 — hỏi lại để xác nhận điều đã đoán — đặt cuối câu hỏi</a:t>
-            </a:r>
-          </a:p>
-          <a:p>
-            <a:pPr>
-              <a:spcBef>
-                <a:spcPts val="400"/>
-              </a:spcBef>
-              <a:buNone/>
-            </a:pPr>
-            <a:r>
-              <a:rPr sz="1700" b="0" i="0">
-                <a:solidFill>
-                  <a:srgbClr val="1F2933"/>
-                </a:solidFill>
-                <a:latin typeface="Calibri"/>
-                <a:ea typeface="Microsoft YaHei"/>
-                <a:cs typeface="Microsoft YaHei"/>
-              </a:rPr>
-              <a:t>   </a:t>
-            </a:r>
-            <a:r>
-              <a:rPr sz="1700" b="0" i="0">
-                <a:solidFill>
-                  <a:srgbClr val="1F2933"/>
-                </a:solidFill>
-                <a:latin typeface="Calibri"/>
-                <a:ea typeface="Microsoft YaHei"/>
-                <a:cs typeface="Microsoft YaHei"/>
-              </a:rPr>
-              <a:t>吧 / 学生 / 你 / 是</a:t>
+              <a:t>Mỗi nhóm 1 dạng bài tập khác nhau: sắp xếp câu, điền từ, trắc nghiệm, tìm lỗi sai, dịch nhanh, đúng/sai</a:t>
             </a:r>
           </a:p>
           <a:p>
@@ -9764,7 +10080,7 @@
                 <a:ea typeface="Microsoft YaHei"/>
                 <a:cs typeface="Microsoft YaHei"/>
               </a:rPr>
-              <a:t>2. </a:t>
+              <a:t>•  </a:t>
             </a:r>
             <a:r>
               <a:rPr sz="2200" b="1" i="0">
@@ -9775,37 +10091,7 @@
                 <a:ea typeface="Microsoft YaHei"/>
                 <a:cs typeface="Microsoft YaHei"/>
               </a:rPr>
-              <a:t>是…的 — nhấn mạnh thời gian/nơi/cách đã xảy ra — 是…的 kẹp quanh phần muốn nhấn mạnh</a:t>
-            </a:r>
-          </a:p>
-          <a:p>
-            <a:pPr>
-              <a:spcBef>
-                <a:spcPts val="400"/>
-              </a:spcBef>
-              <a:buNone/>
-            </a:pPr>
-            <a:r>
-              <a:rPr sz="1700" b="0" i="0">
-                <a:solidFill>
-                  <a:srgbClr val="1F2933"/>
-                </a:solidFill>
-                <a:latin typeface="Calibri"/>
-                <a:ea typeface="Microsoft YaHei"/>
-                <a:cs typeface="Microsoft YaHei"/>
-              </a:rPr>
-              <a:t>   </a:t>
-            </a:r>
-            <a:r>
-              <a:rPr sz="1700" b="0" i="0">
-                <a:solidFill>
-                  <a:srgbClr val="1F2933"/>
-                </a:solidFill>
-                <a:latin typeface="Calibri"/>
-                <a:ea typeface="Microsoft YaHei"/>
-                <a:cs typeface="Microsoft YaHei"/>
-              </a:rPr>
-              <a:t>来 / 你 / 什么时候 / 是 / 的</a:t>
+              <a:t>Một số câu bài tập lấy TRỰC TIẾP từ đề thi 官方样卷 HSK2 (đánh dấu 【官方样卷】)</a:t>
             </a:r>
           </a:p>
           <a:p>
@@ -9824,7 +10110,7 @@
                 <a:ea typeface="Microsoft YaHei"/>
                 <a:cs typeface="Microsoft YaHei"/>
               </a:rPr>
-              <a:t>3. </a:t>
+              <a:t>•  </a:t>
             </a:r>
             <a:r>
               <a:rPr sz="2200" b="1" i="0">
@@ -9835,37 +10121,7 @@
                 <a:ea typeface="Microsoft YaHei"/>
                 <a:cs typeface="Microsoft YaHei"/>
               </a:rPr>
-              <a:t>请/让/叫 — sai khiến/nhờ người khác làm gì — A + 请/让/叫 + B + động từ</a:t>
-            </a:r>
-          </a:p>
-          <a:p>
-            <a:pPr>
-              <a:spcBef>
-                <a:spcPts val="400"/>
-              </a:spcBef>
-              <a:buNone/>
-            </a:pPr>
-            <a:r>
-              <a:rPr sz="1700" b="0" i="0">
-                <a:solidFill>
-                  <a:srgbClr val="1F2933"/>
-                </a:solidFill>
-                <a:latin typeface="Calibri"/>
-                <a:ea typeface="Microsoft YaHei"/>
-                <a:cs typeface="Microsoft YaHei"/>
-              </a:rPr>
-              <a:t>   </a:t>
-            </a:r>
-            <a:r>
-              <a:rPr sz="1700" b="0" i="0">
-                <a:solidFill>
-                  <a:srgbClr val="1F2933"/>
-                </a:solidFill>
-                <a:latin typeface="Calibri"/>
-                <a:ea typeface="Microsoft YaHei"/>
-                <a:cs typeface="Microsoft YaHei"/>
-              </a:rPr>
-              <a:t>问题 / 老师 / 回答 / 让 / 学生</a:t>
+              <a:t>Không học nội dung mới — chỉ ôn tập và luyện phản xạ</a:t>
             </a:r>
           </a:p>
         </p:txBody>
@@ -10028,7 +10284,7 @@
                 <a:ea typeface="Microsoft YaHei"/>
                 <a:cs typeface="Microsoft YaHei"/>
               </a:rPr>
-              <a:t>练习 2/17 · Bài 2</a:t>
+              <a:t>练习 1/17 · Bài 1</a:t>
             </a:r>
           </a:p>
         </p:txBody>
@@ -10067,7 +10323,7 @@
                 <a:ea typeface="Microsoft YaHei"/>
                 <a:cs typeface="Microsoft YaHei"/>
               </a:rPr>
-              <a:t>Điền từ vào chỗ trống</a:t>
+              <a:t>Sắp xếp thành câu đúng</a:t>
             </a:r>
           </a:p>
         </p:txBody>
@@ -10106,7 +10362,7 @@
                 <a:ea typeface="Microsoft YaHei"/>
                 <a:cs typeface="Microsoft YaHei"/>
               </a:rPr>
-              <a:t>Điền từ thích hợp vào chỗ trống:</a:t>
+              <a:t>Sắp xếp các từ sau thành câu đúng:</a:t>
             </a:r>
           </a:p>
           <a:p>
@@ -10136,7 +10392,7 @@
                 <a:ea typeface="Microsoft YaHei"/>
                 <a:cs typeface="Microsoft YaHei"/>
               </a:rPr>
-              <a:t>还是…吧 — gợi ý nghiêng về 1 phương án — 还是 + hành động + 吧</a:t>
+              <a:t>吧 — hỏi lại để xác nhận điều đã đoán — đặt cuối câu hỏi</a:t>
             </a:r>
           </a:p>
           <a:p>
@@ -10166,7 +10422,7 @@
                 <a:ea typeface="Microsoft YaHei"/>
                 <a:cs typeface="Microsoft YaHei"/>
               </a:rPr>
-              <a:t>我们 ___ 坐地铁去吧。</a:t>
+              <a:t>吧 / 学生 / 你 / 是</a:t>
             </a:r>
           </a:p>
           <a:p>
@@ -10196,7 +10452,7 @@
                 <a:ea typeface="Microsoft YaHei"/>
                 <a:cs typeface="Microsoft YaHei"/>
               </a:rPr>
-              <a:t>多 — số lẻ, hơn/mấy — số từ + 多 (+ lượng từ)</a:t>
+              <a:t>是…的 — nhấn mạnh thời gian/nơi/cách đã xảy ra — 是…的 kẹp quanh phần muốn nhấn mạnh</a:t>
             </a:r>
           </a:p>
           <a:p>
@@ -10226,7 +10482,7 @@
                 <a:ea typeface="Microsoft YaHei"/>
                 <a:cs typeface="Microsoft YaHei"/>
               </a:rPr>
-              <a:t>教室里有二十 ___ 个学生。</a:t>
+              <a:t>来 / 你 / 什么时候 / 是 / 的</a:t>
             </a:r>
           </a:p>
           <a:p>
@@ -10256,7 +10512,7 @@
                 <a:ea typeface="Microsoft YaHei"/>
                 <a:cs typeface="Microsoft YaHei"/>
               </a:rPr>
-              <a:t>的(định ngữ) — cụm từ bổ nghĩa cho danh từ — cụm từ + 的 + danh từ</a:t>
+              <a:t>请/让/叫 — sai khiến/nhờ người khác làm gì — A + 请/让/叫 + B + động từ</a:t>
             </a:r>
           </a:p>
           <a:p>
@@ -10286,7 +10542,7 @@
                 <a:ea typeface="Microsoft YaHei"/>
                 <a:cs typeface="Microsoft YaHei"/>
               </a:rPr>
-              <a:t>这些书是朋友们送 ___ 。</a:t>
+              <a:t>问题 / 老师 / 回答 / 让 / 学生</a:t>
             </a:r>
           </a:p>
         </p:txBody>
@@ -10449,7 +10705,7 @@
                 <a:ea typeface="Microsoft YaHei"/>
                 <a:cs typeface="Microsoft YaHei"/>
               </a:rPr>
-              <a:t>练习 3/17 · Bài 3</a:t>
+              <a:t>练习 2/17 · Bài 2</a:t>
             </a:r>
           </a:p>
         </p:txBody>
@@ -10488,7 +10744,7 @@
                 <a:ea typeface="Microsoft YaHei"/>
                 <a:cs typeface="Microsoft YaHei"/>
               </a:rPr>
-              <a:t>Trắc nghiệm chọn câu đúng</a:t>
+              <a:t>Điền từ vào chỗ trống</a:t>
             </a:r>
           </a:p>
         </p:txBody>
@@ -10527,7 +10783,7 @@
                 <a:ea typeface="Microsoft YaHei"/>
                 <a:cs typeface="Microsoft YaHei"/>
               </a:rPr>
-              <a:t>Chọn câu ĐÚNG cho ý nghĩa cho sẵn:</a:t>
+              <a:t>Điền từ thích hợp vào chỗ trống:</a:t>
             </a:r>
           </a:p>
           <a:p>
@@ -10557,7 +10813,7 @@
                 <a:ea typeface="Microsoft YaHei"/>
                 <a:cs typeface="Microsoft YaHei"/>
               </a:rPr>
-              <a:t>动词重叠 — làm thử/nhẹ nhàng, thời gian ngắn — lặp lại động từ (AA/ABAB/AAB)</a:t>
+              <a:t>还是…吧 — gợi ý nghiêng về 1 phương án — 还是 + hành động + 吧</a:t>
             </a:r>
           </a:p>
           <a:p>
@@ -10587,7 +10843,7 @@
                 <a:ea typeface="Microsoft YaHei"/>
                 <a:cs typeface="Microsoft YaHei"/>
               </a:rPr>
-              <a:t>'Thử nghe nhạc một chút' — A) 我听音乐音乐  B) 我听听音乐  C) 我听了音乐音乐</a:t>
+              <a:t>我们 ___ 坐地铁去吧。</a:t>
             </a:r>
           </a:p>
           <a:p>
@@ -10617,7 +10873,97 @@
                 <a:ea typeface="Microsoft YaHei"/>
                 <a:cs typeface="Microsoft YaHei"/>
               </a:rPr>
-              <a:t>'Đã giúp một tay rồi' — A) 他帮了帮忙  B) 他帮帮了忙  C) 他帮忙了帮</a:t>
+              <a:t>多 — số lẻ, hơn/mấy — số từ + 多 (+ lượng từ)</a:t>
+            </a:r>
+          </a:p>
+          <a:p>
+            <a:pPr>
+              <a:spcBef>
+                <a:spcPts val="400"/>
+              </a:spcBef>
+              <a:buNone/>
+            </a:pPr>
+            <a:r>
+              <a:rPr sz="1700" b="0" i="0">
+                <a:solidFill>
+                  <a:srgbClr val="1F2933"/>
+                </a:solidFill>
+                <a:latin typeface="Calibri"/>
+                <a:ea typeface="Microsoft YaHei"/>
+                <a:cs typeface="Microsoft YaHei"/>
+              </a:rPr>
+              <a:t>   </a:t>
+            </a:r>
+            <a:r>
+              <a:rPr sz="1700" b="0" i="0">
+                <a:solidFill>
+                  <a:srgbClr val="1F2933"/>
+                </a:solidFill>
+                <a:latin typeface="Calibri"/>
+                <a:ea typeface="Microsoft YaHei"/>
+                <a:cs typeface="Microsoft YaHei"/>
+              </a:rPr>
+              <a:t>教室里有二十 ___ 个学生。</a:t>
+            </a:r>
+          </a:p>
+          <a:p>
+            <a:pPr>
+              <a:spcBef>
+                <a:spcPts val="2600"/>
+              </a:spcBef>
+              <a:buNone/>
+            </a:pPr>
+            <a:r>
+              <a:rPr sz="2200" b="1" i="0">
+                <a:solidFill>
+                  <a:srgbClr val="8E2B20"/>
+                </a:solidFill>
+                <a:latin typeface="Calibri"/>
+                <a:ea typeface="Microsoft YaHei"/>
+                <a:cs typeface="Microsoft YaHei"/>
+              </a:rPr>
+              <a:t>3. </a:t>
+            </a:r>
+            <a:r>
+              <a:rPr sz="2200" b="1" i="0">
+                <a:solidFill>
+                  <a:srgbClr val="1F2933"/>
+                </a:solidFill>
+                <a:latin typeface="Calibri"/>
+                <a:ea typeface="Microsoft YaHei"/>
+                <a:cs typeface="Microsoft YaHei"/>
+              </a:rPr>
+              <a:t>的(định ngữ) — cụm từ bổ nghĩa cho danh từ — cụm từ + 的 + danh từ</a:t>
+            </a:r>
+          </a:p>
+          <a:p>
+            <a:pPr>
+              <a:spcBef>
+                <a:spcPts val="400"/>
+              </a:spcBef>
+              <a:buNone/>
+            </a:pPr>
+            <a:r>
+              <a:rPr sz="1700" b="0" i="0">
+                <a:solidFill>
+                  <a:srgbClr val="1F2933"/>
+                </a:solidFill>
+                <a:latin typeface="Calibri"/>
+                <a:ea typeface="Microsoft YaHei"/>
+                <a:cs typeface="Microsoft YaHei"/>
+              </a:rPr>
+              <a:t>   </a:t>
+            </a:r>
+            <a:r>
+              <a:rPr sz="1700" b="0" i="0">
+                <a:solidFill>
+                  <a:srgbClr val="1F2933"/>
+                </a:solidFill>
+                <a:latin typeface="Calibri"/>
+                <a:ea typeface="Microsoft YaHei"/>
+                <a:cs typeface="Microsoft YaHei"/>
+              </a:rPr>
+              <a:t>这些书是朋友们送 ___ 。</a:t>
             </a:r>
           </a:p>
         </p:txBody>
@@ -10780,7 +11126,7 @@
                 <a:ea typeface="Microsoft YaHei"/>
                 <a:cs typeface="Microsoft YaHei"/>
               </a:rPr>
-              <a:t>练习 4/17 · Bài 4</a:t>
+              <a:t>练习 3/17 · Bài 3</a:t>
             </a:r>
           </a:p>
         </p:txBody>
@@ -10819,7 +11165,7 @@
                 <a:ea typeface="Microsoft YaHei"/>
                 <a:cs typeface="Microsoft YaHei"/>
               </a:rPr>
-              <a:t>Tìm và sửa câu sai</a:t>
+              <a:t>Trắc nghiệm chọn câu đúng</a:t>
             </a:r>
           </a:p>
         </p:txBody>
@@ -10858,7 +11204,7 @@
                 <a:ea typeface="Microsoft YaHei"/>
                 <a:cs typeface="Microsoft YaHei"/>
               </a:rPr>
-              <a:t>Mỗi câu sau có 1 lỗi — tìm và sửa lại:</a:t>
+              <a:t>Chọn câu ĐÚNG cho ý nghĩa cho sẵn:</a:t>
             </a:r>
           </a:p>
           <a:p>
@@ -10888,7 +11234,7 @@
                 <a:ea typeface="Microsoft YaHei"/>
                 <a:cs typeface="Microsoft YaHei"/>
               </a:rPr>
-              <a:t>过 — đã từng làm (kinh nghiệm) — động từ + 过</a:t>
+              <a:t>动词重叠 — làm thử/nhẹ nhàng, thời gian ngắn — lặp lại động từ (AA/ABAB/AAB)</a:t>
             </a:r>
           </a:p>
           <a:p>
@@ -10918,7 +11264,7 @@
                 <a:ea typeface="Microsoft YaHei"/>
                 <a:cs typeface="Microsoft YaHei"/>
               </a:rPr>
-              <a:t>她穿过去年这件衣服一次。</a:t>
+              <a:t>'Thử nghe nhạc một chút' — A) 我听音乐音乐  B) 我听听音乐  C) 我听了音乐音乐</a:t>
             </a:r>
           </a:p>
           <a:p>
@@ -10948,97 +11294,7 @@
                 <a:ea typeface="Microsoft YaHei"/>
                 <a:cs typeface="Microsoft YaHei"/>
               </a:rPr>
-              <a:t>因为…所以 — vì A nên B — 因为 + lý do，所以 + kết quả</a:t>
-            </a:r>
-          </a:p>
-          <a:p>
-            <a:pPr>
-              <a:spcBef>
-                <a:spcPts val="400"/>
-              </a:spcBef>
-              <a:buNone/>
-            </a:pPr>
-            <a:r>
-              <a:rPr sz="1700" b="0" i="0">
-                <a:solidFill>
-                  <a:srgbClr val="1F2933"/>
-                </a:solidFill>
-                <a:latin typeface="Calibri"/>
-                <a:ea typeface="Microsoft YaHei"/>
-                <a:cs typeface="Microsoft YaHei"/>
-              </a:rPr>
-              <a:t>   </a:t>
-            </a:r>
-            <a:r>
-              <a:rPr sz="1700" b="0" i="0">
-                <a:solidFill>
-                  <a:srgbClr val="1F2933"/>
-                </a:solidFill>
-                <a:latin typeface="Calibri"/>
-                <a:ea typeface="Microsoft YaHei"/>
-                <a:cs typeface="Microsoft YaHei"/>
-              </a:rPr>
-              <a:t>所以我生病了，因为没去上班。</a:t>
-            </a:r>
-          </a:p>
-          <a:p>
-            <a:pPr>
-              <a:spcBef>
-                <a:spcPts val="2600"/>
-              </a:spcBef>
-              <a:buNone/>
-            </a:pPr>
-            <a:r>
-              <a:rPr sz="2200" b="1" i="0">
-                <a:solidFill>
-                  <a:srgbClr val="8E2B20"/>
-                </a:solidFill>
-                <a:latin typeface="Calibri"/>
-                <a:ea typeface="Microsoft YaHei"/>
-                <a:cs typeface="Microsoft YaHei"/>
-              </a:rPr>
-              <a:t>3. </a:t>
-            </a:r>
-            <a:r>
-              <a:rPr sz="2200" b="1" i="0">
-                <a:solidFill>
-                  <a:srgbClr val="1F2933"/>
-                </a:solidFill>
-                <a:latin typeface="Calibri"/>
-                <a:ea typeface="Microsoft YaHei"/>
-                <a:cs typeface="Microsoft YaHei"/>
-              </a:rPr>
-              <a:t>的字短语(lược bỏ) — khỏi lặp lại danh từ đã nhắc — cụm từ + 的 (bỏ danh từ)</a:t>
-            </a:r>
-          </a:p>
-          <a:p>
-            <a:pPr>
-              <a:spcBef>
-                <a:spcPts val="400"/>
-              </a:spcBef>
-              <a:buNone/>
-            </a:pPr>
-            <a:r>
-              <a:rPr sz="1700" b="0" i="0">
-                <a:solidFill>
-                  <a:srgbClr val="1F2933"/>
-                </a:solidFill>
-                <a:latin typeface="Calibri"/>
-                <a:ea typeface="Microsoft YaHei"/>
-                <a:cs typeface="Microsoft YaHei"/>
-              </a:rPr>
-              <a:t>   </a:t>
-            </a:r>
-            <a:r>
-              <a:rPr sz="1700" b="0" i="0">
-                <a:solidFill>
-                  <a:srgbClr val="1F2933"/>
-                </a:solidFill>
-                <a:latin typeface="Calibri"/>
-                <a:ea typeface="Microsoft YaHei"/>
-                <a:cs typeface="Microsoft YaHei"/>
-              </a:rPr>
-              <a:t>这件衣服太贵了，还是买那件红色衣服吧。</a:t>
+              <a:t>'Đã giúp một tay rồi' — A) 他帮了帮忙  B) 他帮帮了忙  C) 他帮忙了帮</a:t>
             </a:r>
           </a:p>
         </p:txBody>
@@ -11158,7 +11414,7 @@
         <p:spPr>
           <a:xfrm>
             <a:off x="548640" y="146304"/>
-            <a:ext cx="2922747" cy="384048"/>
+            <a:ext cx="2349235" cy="384048"/>
           </a:xfrm>
           <a:prstGeom prst="roundRect">
             <a:avLst/>
@@ -11201,7 +11457,7 @@
                 <a:ea typeface="Microsoft YaHei"/>
                 <a:cs typeface="Microsoft YaHei"/>
               </a:rPr>
-              <a:t>练习 5/17 · Bài 4 拓展</a:t>
+              <a:t>练习 4/17 · Bài 4</a:t>
             </a:r>
           </a:p>
         </p:txBody>
@@ -11240,7 +11496,7 @@
                 <a:ea typeface="Microsoft YaHei"/>
                 <a:cs typeface="Microsoft YaHei"/>
               </a:rPr>
-              <a:t>Dịch nhanh Việt → Trung</a:t>
+              <a:t>Tìm và sửa câu sai</a:t>
             </a:r>
           </a:p>
         </p:txBody>
@@ -11279,7 +11535,7 @@
                 <a:ea typeface="Microsoft YaHei"/>
                 <a:cs typeface="Microsoft YaHei"/>
               </a:rPr>
-              <a:t>Dịch nhanh sang tiếng Trung, dùng 把:</a:t>
+              <a:t>Mỗi câu sau có 1 lỗi — tìm và sửa lại:</a:t>
             </a:r>
           </a:p>
           <a:p>
@@ -11309,7 +11565,7 @@
                 <a:ea typeface="Microsoft YaHei"/>
                 <a:cs typeface="Microsoft YaHei"/>
               </a:rPr>
-              <a:t>把字句 — đưa vật cụ thể lên trước động từ — 把 + vật + động từ + phần còn lại</a:t>
+              <a:t>过 — đã từng làm (kinh nghiệm) — động từ + 过</a:t>
             </a:r>
           </a:p>
           <a:p>
@@ -11339,7 +11595,7 @@
                 <a:ea typeface="Microsoft YaHei"/>
                 <a:cs typeface="Microsoft YaHei"/>
               </a:rPr>
-              <a:t>Hãy treo cái áo lên đi.</a:t>
+              <a:t>她穿过去年这件衣服一次。</a:t>
             </a:r>
           </a:p>
           <a:p>
@@ -11369,7 +11625,97 @@
                 <a:ea typeface="Microsoft YaHei"/>
                 <a:cs typeface="Microsoft YaHei"/>
               </a:rPr>
-              <a:t>Bạn đã lau sạch cái bàn chưa?</a:t>
+              <a:t>因为…所以 — vì A nên B — 因为 + lý do，所以 + kết quả</a:t>
+            </a:r>
+          </a:p>
+          <a:p>
+            <a:pPr>
+              <a:spcBef>
+                <a:spcPts val="400"/>
+              </a:spcBef>
+              <a:buNone/>
+            </a:pPr>
+            <a:r>
+              <a:rPr sz="1700" b="0" i="0">
+                <a:solidFill>
+                  <a:srgbClr val="1F2933"/>
+                </a:solidFill>
+                <a:latin typeface="Calibri"/>
+                <a:ea typeface="Microsoft YaHei"/>
+                <a:cs typeface="Microsoft YaHei"/>
+              </a:rPr>
+              <a:t>   </a:t>
+            </a:r>
+            <a:r>
+              <a:rPr sz="1700" b="0" i="0">
+                <a:solidFill>
+                  <a:srgbClr val="1F2933"/>
+                </a:solidFill>
+                <a:latin typeface="Calibri"/>
+                <a:ea typeface="Microsoft YaHei"/>
+                <a:cs typeface="Microsoft YaHei"/>
+              </a:rPr>
+              <a:t>所以我生病了，因为没去上班。</a:t>
+            </a:r>
+          </a:p>
+          <a:p>
+            <a:pPr>
+              <a:spcBef>
+                <a:spcPts val="2600"/>
+              </a:spcBef>
+              <a:buNone/>
+            </a:pPr>
+            <a:r>
+              <a:rPr sz="2200" b="1" i="0">
+                <a:solidFill>
+                  <a:srgbClr val="8E2B20"/>
+                </a:solidFill>
+                <a:latin typeface="Calibri"/>
+                <a:ea typeface="Microsoft YaHei"/>
+                <a:cs typeface="Microsoft YaHei"/>
+              </a:rPr>
+              <a:t>3. </a:t>
+            </a:r>
+            <a:r>
+              <a:rPr sz="2200" b="1" i="0">
+                <a:solidFill>
+                  <a:srgbClr val="1F2933"/>
+                </a:solidFill>
+                <a:latin typeface="Calibri"/>
+                <a:ea typeface="Microsoft YaHei"/>
+                <a:cs typeface="Microsoft YaHei"/>
+              </a:rPr>
+              <a:t>的字短语(lược bỏ) — khỏi lặp lại danh từ đã nhắc — cụm từ + 的 (bỏ danh từ)</a:t>
+            </a:r>
+          </a:p>
+          <a:p>
+            <a:pPr>
+              <a:spcBef>
+                <a:spcPts val="400"/>
+              </a:spcBef>
+              <a:buNone/>
+            </a:pPr>
+            <a:r>
+              <a:rPr sz="1700" b="0" i="0">
+                <a:solidFill>
+                  <a:srgbClr val="1F2933"/>
+                </a:solidFill>
+                <a:latin typeface="Calibri"/>
+                <a:ea typeface="Microsoft YaHei"/>
+                <a:cs typeface="Microsoft YaHei"/>
+              </a:rPr>
+              <a:t>   </a:t>
+            </a:r>
+            <a:r>
+              <a:rPr sz="1700" b="0" i="0">
+                <a:solidFill>
+                  <a:srgbClr val="1F2933"/>
+                </a:solidFill>
+                <a:latin typeface="Calibri"/>
+                <a:ea typeface="Microsoft YaHei"/>
+                <a:cs typeface="Microsoft YaHei"/>
+              </a:rPr>
+              <a:t>这件衣服太贵了，还是买那件红色衣服吧。</a:t>
             </a:r>
           </a:p>
         </p:txBody>
@@ -11489,7 +11835,7 @@
         <p:spPr>
           <a:xfrm>
             <a:off x="548640" y="146304"/>
-            <a:ext cx="2349235" cy="384048"/>
+            <a:ext cx="2922747" cy="384048"/>
           </a:xfrm>
           <a:prstGeom prst="roundRect">
             <a:avLst/>
@@ -11532,7 +11878,7 @@
                 <a:ea typeface="Microsoft YaHei"/>
                 <a:cs typeface="Microsoft YaHei"/>
               </a:rPr>
-              <a:t>练习 6/17 · Bài 5</a:t>
+              <a:t>练习 5/17 · Bài 4 拓展</a:t>
             </a:r>
           </a:p>
         </p:txBody>
@@ -11571,7 +11917,7 @@
                 <a:ea typeface="Microsoft YaHei"/>
                 <a:cs typeface="Microsoft YaHei"/>
               </a:rPr>
-              <a:t>Đúng hay Sai?</a:t>
+              <a:t>Dịch nhanh Việt → Trung</a:t>
             </a:r>
           </a:p>
         </p:txBody>
@@ -11610,7 +11956,7 @@
                 <a:ea typeface="Microsoft YaHei"/>
                 <a:cs typeface="Microsoft YaHei"/>
               </a:rPr>
-              <a:t>Nhận định sau ĐÚNG hay SAI?</a:t>
+              <a:t>Dịch nhanh sang tiếng Trung, dùng 把:</a:t>
             </a:r>
           </a:p>
           <a:p>
@@ -11640,7 +11986,7 @@
                 <a:ea typeface="Microsoft YaHei"/>
                 <a:cs typeface="Microsoft YaHei"/>
               </a:rPr>
-              <a:t>简单/复合趋向补语 — chỉ hướng di chuyển — động từ + 来/去/上/下...</a:t>
+              <a:t>把字句 — đưa vật cụ thể lên trước động từ — 把 + vật + động từ + phần còn lại</a:t>
             </a:r>
           </a:p>
           <a:p>
@@ -11670,7 +12016,7 @@
                 <a:ea typeface="Microsoft YaHei"/>
                 <a:cs typeface="Microsoft YaHei"/>
               </a:rPr>
-              <a:t>'他走进教室来了' nghĩa là anh ấy đang đi RA khỏi lớp.</a:t>
+              <a:t>Hãy treo cái áo lên đi.</a:t>
             </a:r>
           </a:p>
           <a:p>
@@ -11700,37 +12046,7 @@
                 <a:ea typeface="Microsoft YaHei"/>
                 <a:cs typeface="Microsoft YaHei"/>
               </a:rPr>
-              <a:t>都…了 — nhấn mạnh đã muộn/đến lúc — 都 + mốc thời gian + 了</a:t>
-            </a:r>
-          </a:p>
-          <a:p>
-            <a:pPr>
-              <a:spcBef>
-                <a:spcPts val="400"/>
-              </a:spcBef>
-              <a:buNone/>
-            </a:pPr>
-            <a:r>
-              <a:rPr sz="1700" b="0" i="0">
-                <a:solidFill>
-                  <a:srgbClr val="1F2933"/>
-                </a:solidFill>
-                <a:latin typeface="Calibri"/>
-                <a:ea typeface="Microsoft YaHei"/>
-                <a:cs typeface="Microsoft YaHei"/>
-              </a:rPr>
-              <a:t>   </a:t>
-            </a:r>
-            <a:r>
-              <a:rPr sz="1700" b="0" i="0">
-                <a:solidFill>
-                  <a:srgbClr val="1F2933"/>
-                </a:solidFill>
-                <a:latin typeface="Calibri"/>
-                <a:ea typeface="Microsoft YaHei"/>
-                <a:cs typeface="Microsoft YaHei"/>
-              </a:rPr>
-              <a:t>'都十点了' dùng để nhắc rằng đã muộn/đến giờ rồi.</a:t>
+              <a:t>Bạn đã lau sạch cái bàn chưa?</a:t>
             </a:r>
           </a:p>
         </p:txBody>
@@ -11850,7 +12166,7 @@
         <p:spPr>
           <a:xfrm>
             <a:off x="548640" y="146304"/>
-            <a:ext cx="2585923" cy="384048"/>
+            <a:ext cx="2349235" cy="384048"/>
           </a:xfrm>
           <a:prstGeom prst="roundRect">
             <a:avLst/>
@@ -11893,7 +12209,7 @@
                 <a:ea typeface="Microsoft YaHei"/>
                 <a:cs typeface="Microsoft YaHei"/>
               </a:rPr>
-              <a:t>练习 7/17 · Bài 6-7</a:t>
+              <a:t>练习 6/17 · Bài 5</a:t>
             </a:r>
           </a:p>
         </p:txBody>
@@ -11932,7 +12248,7 @@
                 <a:ea typeface="Microsoft YaHei"/>
                 <a:cs typeface="Microsoft YaHei"/>
               </a:rPr>
-              <a:t>Điền từ vào chỗ trống</a:t>
+              <a:t>Đúng hay Sai?</a:t>
             </a:r>
           </a:p>
         </p:txBody>
@@ -11971,7 +12287,7 @@
                 <a:ea typeface="Microsoft YaHei"/>
                 <a:cs typeface="Microsoft YaHei"/>
               </a:rPr>
-              <a:t>Điền chữ còn thiếu:</a:t>
+              <a:t>Nhận định sau ĐÚNG hay SAI?</a:t>
             </a:r>
           </a:p>
           <a:p>
@@ -12001,7 +12317,7 @@
                 <a:ea typeface="Microsoft YaHei"/>
                 <a:cs typeface="Microsoft YaHei"/>
               </a:rPr>
-              <a:t>状态补语 得 — nói làm như thế nào — động từ + 得 + tính từ</a:t>
+              <a:t>简单/复合趋向补语 — chỉ hướng di chuyển — động từ + 来/去/上/下...</a:t>
             </a:r>
           </a:p>
           <a:p>
@@ -12031,7 +12347,7 @@
                 <a:ea typeface="Microsoft YaHei"/>
                 <a:cs typeface="Microsoft YaHei"/>
               </a:rPr>
-              <a:t>他昨天睡 ___ 很晚。</a:t>
+              <a:t>'他走进教室来了' nghĩa là anh ấy đang đi RA khỏi lớp.</a:t>
             </a:r>
           </a:p>
           <a:p>
@@ -12061,7 +12377,37 @@
                 <a:ea typeface="Microsoft YaHei"/>
                 <a:cs typeface="Microsoft YaHei"/>
               </a:rPr>
-              <a:t>她住 ___ 很远，我想送她回去。</a:t>
+              <a:t>都…了 — nhấn mạnh đã muộn/đến lúc — 都 + mốc thời gian + 了</a:t>
+            </a:r>
+          </a:p>
+          <a:p>
+            <a:pPr>
+              <a:spcBef>
+                <a:spcPts val="400"/>
+              </a:spcBef>
+              <a:buNone/>
+            </a:pPr>
+            <a:r>
+              <a:rPr sz="1700" b="0" i="0">
+                <a:solidFill>
+                  <a:srgbClr val="1F2933"/>
+                </a:solidFill>
+                <a:latin typeface="Calibri"/>
+                <a:ea typeface="Microsoft YaHei"/>
+                <a:cs typeface="Microsoft YaHei"/>
+              </a:rPr>
+              <a:t>   </a:t>
+            </a:r>
+            <a:r>
+              <a:rPr sz="1700" b="0" i="0">
+                <a:solidFill>
+                  <a:srgbClr val="1F2933"/>
+                </a:solidFill>
+                <a:latin typeface="Calibri"/>
+                <a:ea typeface="Microsoft YaHei"/>
+                <a:cs typeface="Microsoft YaHei"/>
+              </a:rPr>
+              <a:t>'都十点了' dùng để nhắc rằng đã muộn/đến giờ rồi.</a:t>
             </a:r>
           </a:p>
         </p:txBody>

</xml_diff>